<commit_message>
refresh live memory into repo
</commit_message>
<xml_diff>
--- a/brainstorm/QueryCopilot_Highlight.pptx
+++ b/brainstorm/QueryCopilot_Highlight.pptx
@@ -14,6 +14,8 @@
     <p:sldId id="259" r:id="rId5"/>
     <p:sldId id="260" r:id="rId6"/>
     <p:sldId id="261" r:id="rId7"/>
+    <p:sldId id="262" r:id="rId13"/>
+    <p:sldId id="263" r:id="rId14"/>
   </p:sldIdLst>
   <p:sldSz cx="12192000" cy="6858000"/>
   <p:notesSz cx="6858000" cy="12192000"/>
@@ -12260,6 +12262,3689 @@
                 <a:cs typeface="Arial" pitchFamily="34" charset="-120"/>
               </a:rPr>
               <a:t>Declarative catalog + LLM restricted to selecting from it + deterministic compiler underneath — that's exactly how these products work internally. We apply the same pattern to our own API layer instead of paying for it to be applied to a warehouse we're not centered on.</a:t>
+            </a:r>
+            <a:endParaRPr lang="en-US" sz="1050" dirty="0"/>
+          </a:p>
+        </p:txBody>
+      </p:sp>
+    </p:spTree>
+  </p:cSld>
+  <p:clrMapOvr>
+    <a:masterClrMapping/>
+  </p:clrMapOvr>
+</p:sld>
+</file>
+
+<file path=ppt/slides/slide7.xml><?xml version="1.0" encoding="utf-8"?>
+<p:sld xmlns:a="http://schemas.openxmlformats.org/drawingml/2006/main" xmlns:r="http://schemas.openxmlformats.org/officeDocument/2006/relationships" xmlns:p="http://schemas.openxmlformats.org/presentationml/2006/main">
+  <p:cSld name="Slide 2">
+    <p:spTree>
+      <p:nvGrpSpPr>
+        <p:cNvPr id="1" name=""/>
+        <p:cNvGrpSpPr/>
+        <p:nvPr/>
+      </p:nvGrpSpPr>
+      <p:grpSpPr>
+        <a:xfrm>
+          <a:off x="0" y="0"/>
+          <a:ext cx="0" cy="0"/>
+          <a:chOff x="0" y="0"/>
+          <a:chExt cx="0" cy="0"/>
+        </a:xfrm>
+      </p:grpSpPr>
+      <p:sp>
+        <p:nvSpPr>
+          <p:cNvPr id="2" name="Shape 0"/>
+          <p:cNvSpPr/>
+          <p:nvPr/>
+        </p:nvSpPr>
+        <p:spPr>
+          <a:xfrm>
+            <a:off x="0" y="0"/>
+            <a:ext cx="4114800" cy="6858000"/>
+          </a:xfrm>
+          <a:prstGeom prst="rect">
+            <a:avLst/>
+          </a:prstGeom>
+          <a:solidFill>
+            <a:srgbClr val="3B4652"/>
+          </a:solidFill>
+          <a:ln/>
+        </p:spPr>
+        <p:txBody>
+          <a:bodyPr/>
+          <a:lstStyle/>
+          <a:p>
+            <a:endParaRPr lang="en-US"/>
+          </a:p>
+        </p:txBody>
+      </p:sp>
+      <p:sp>
+        <p:nvSpPr>
+          <p:cNvPr id="3" name="Shape 1"/>
+          <p:cNvSpPr/>
+          <p:nvPr/>
+        </p:nvSpPr>
+        <p:spPr>
+          <a:xfrm>
+            <a:off x="457200" y="457200"/>
+            <a:ext cx="566928" cy="566928"/>
+          </a:xfrm>
+          <a:prstGeom prst="ellipse">
+            <a:avLst/>
+          </a:prstGeom>
+          <a:solidFill>
+            <a:srgbClr val="0098C7"/>
+          </a:solidFill>
+          <a:ln/>
+        </p:spPr>
+        <p:txBody>
+          <a:bodyPr/>
+          <a:lstStyle/>
+          <a:p>
+            <a:endParaRPr lang="en-US"/>
+          </a:p>
+        </p:txBody>
+      </p:sp>
+      <p:pic>
+        <p:nvPicPr>
+          <p:cNvPr id="4" name="Image 0" descr="preencoded.png"/>
+          <p:cNvPicPr>
+            <a:picLocks noChangeAspect="1"/>
+          </p:cNvPicPr>
+          <p:nvPr/>
+        </p:nvPicPr>
+        <p:blipFill>
+          <a:blip r:embed="rId3"/>
+          <a:stretch>
+            <a:fillRect/>
+          </a:stretch>
+        </p:blipFill>
+        <p:spPr>
+          <a:xfrm>
+            <a:off x="576072" y="576072"/>
+            <a:ext cx="329184" cy="329184"/>
+          </a:xfrm>
+          <a:prstGeom prst="rect">
+            <a:avLst/>
+          </a:prstGeom>
+        </p:spPr>
+      </p:pic>
+      <p:sp>
+        <p:nvSpPr>
+          <p:cNvPr id="5" name="Text 2"/>
+          <p:cNvSpPr/>
+          <p:nvPr/>
+        </p:nvSpPr>
+        <p:spPr>
+          <a:xfrm>
+            <a:off x="1170432" y="384048"/>
+            <a:ext cx="2788920" cy="685800"/>
+          </a:xfrm>
+          <a:prstGeom prst="rect">
+            <a:avLst/>
+          </a:prstGeom>
+          <a:noFill/>
+          <a:ln/>
+        </p:spPr>
+        <p:txBody>
+          <a:bodyPr wrap="square" lIns="0" tIns="0" rIns="0" bIns="0" rtlCol="0" anchor="t"/>
+          <a:lstStyle/>
+          <a:p>
+            <a:pPr marL="0" indent="0" algn="l">
+              <a:lnSpc>
+                <a:spcPct val="102000"/>
+              </a:lnSpc>
+              <a:buNone/>
+            </a:pPr>
+            <a:r>
+              <a:rPr lang="en-US" sz="2200" b="1" dirty="0">
+                <a:solidFill>
+                  <a:srgbClr val="FFFFFF"/>
+                </a:solidFill>
+                <a:latin typeface="Arial" pitchFamily="34" charset="0"/>
+                <a:ea typeface="Arial" pitchFamily="34" charset="-122"/>
+                <a:cs typeface="Arial" pitchFamily="34" charset="-120"/>
+              </a:rPr>
+              <a:t>WSD Data Access Co-Pilot</a:t>
+            </a:r>
+            <a:endParaRPr lang="en-US" sz="2200" dirty="0"/>
+          </a:p>
+        </p:txBody>
+      </p:sp>
+      <p:sp>
+        <p:nvSpPr>
+          <p:cNvPr id="6" name="Text 3"/>
+          <p:cNvSpPr/>
+          <p:nvPr/>
+        </p:nvSpPr>
+        <p:spPr>
+          <a:xfrm>
+            <a:off x="429768" y="1170432"/>
+            <a:ext cx="3383280" cy="502920"/>
+          </a:xfrm>
+          <a:prstGeom prst="rect">
+            <a:avLst/>
+          </a:prstGeom>
+          <a:noFill/>
+          <a:ln/>
+        </p:spPr>
+        <p:txBody>
+          <a:bodyPr wrap="square" lIns="0" tIns="0" rIns="0" bIns="0" rtlCol="0" anchor="t"/>
+          <a:lstStyle/>
+          <a:p>
+            <a:pPr marL="0" indent="0" algn="l">
+              <a:buNone/>
+            </a:pPr>
+            <a:r>
+              <a:rPr lang="en-US" sz="1250" dirty="0">
+                <a:solidFill>
+                  <a:srgbClr val="EEEFF0"/>
+                </a:solidFill>
+                <a:latin typeface="Arial" pitchFamily="34" charset="0"/>
+                <a:ea typeface="Arial" pitchFamily="34" charset="-122"/>
+                <a:cs typeface="Arial" pitchFamily="34" charset="-120"/>
+              </a:rPr>
+              <a:t>V2 to-do plan: agent-oriented API transition</a:t>
+            </a:r>
+            <a:endParaRPr lang="en-US" sz="1250" dirty="0"/>
+          </a:p>
+        </p:txBody>
+      </p:sp>
+      <p:sp>
+        <p:nvSpPr>
+          <p:cNvPr id="7" name="Text 4"/>
+          <p:cNvSpPr/>
+          <p:nvPr/>
+        </p:nvSpPr>
+        <p:spPr>
+          <a:xfrm>
+            <a:off x="457200" y="1783080"/>
+            <a:ext cx="3291840" cy="237744"/>
+          </a:xfrm>
+          <a:prstGeom prst="rect">
+            <a:avLst/>
+          </a:prstGeom>
+          <a:noFill/>
+          <a:ln/>
+        </p:spPr>
+        <p:txBody>
+          <a:bodyPr wrap="square" lIns="0" tIns="0" rIns="0" bIns="0" rtlCol="0" anchor="ctr"/>
+          <a:lstStyle/>
+          <a:p>
+            <a:pPr marL="0" indent="0">
+              <a:buNone/>
+            </a:pPr>
+            <a:r>
+              <a:rPr lang="en-US" sz="1100" b="1" dirty="0">
+                <a:solidFill>
+                  <a:srgbClr val="0098C7"/>
+                </a:solidFill>
+                <a:latin typeface="Arial" pitchFamily="34" charset="0"/>
+                <a:ea typeface="Arial" pitchFamily="34" charset="-122"/>
+                <a:cs typeface="Arial" pitchFamily="34" charset="-120"/>
+              </a:rPr>
+              <a:t>THE GOAL</a:t>
+            </a:r>
+            <a:endParaRPr lang="en-US" sz="1100" dirty="0"/>
+          </a:p>
+        </p:txBody>
+      </p:sp>
+      <p:sp>
+        <p:nvSpPr>
+          <p:cNvPr id="8" name="Text 5"/>
+          <p:cNvSpPr/>
+          <p:nvPr/>
+        </p:nvSpPr>
+        <p:spPr>
+          <a:xfrm>
+            <a:off x="457200" y="2039112"/>
+            <a:ext cx="3337560" cy="822960"/>
+          </a:xfrm>
+          <a:prstGeom prst="rect">
+            <a:avLst/>
+          </a:prstGeom>
+          <a:noFill/>
+          <a:ln/>
+        </p:spPr>
+        <p:txBody>
+          <a:bodyPr wrap="square" lIns="0" tIns="0" rIns="0" bIns="0" rtlCol="0" anchor="t"/>
+          <a:lstStyle/>
+          <a:p>
+            <a:pPr marL="0" indent="0">
+              <a:buNone/>
+            </a:pPr>
+            <a:r>
+              <a:rPr lang="en-US" sz="1200" dirty="0">
+                <a:solidFill>
+                  <a:srgbClr val="EEEFF0"/>
+                </a:solidFill>
+                <a:latin typeface="Arial" pitchFamily="34" charset="0"/>
+                <a:ea typeface="Arial" pitchFamily="34" charset="-122"/>
+                <a:cs typeface="Arial" pitchFamily="34" charset="-120"/>
+              </a:rPr>
+              <a:t>Publish the Catalog as agent-callable tools, backed by one typed OpenAPI contract — not a second hand-built layer on top of v1.</a:t>
+            </a:r>
+            <a:endParaRPr lang="en-US" sz="1200" dirty="0"/>
+          </a:p>
+        </p:txBody>
+      </p:sp>
+      <p:sp>
+        <p:nvSpPr>
+          <p:cNvPr id="9" name="Shape 6"/>
+          <p:cNvSpPr/>
+          <p:nvPr/>
+        </p:nvSpPr>
+        <p:spPr>
+          <a:xfrm>
+            <a:off x="457200" y="3017520"/>
+            <a:ext cx="54864" cy="1078992"/>
+          </a:xfrm>
+          <a:prstGeom prst="rect">
+            <a:avLst/>
+          </a:prstGeom>
+          <a:solidFill>
+            <a:srgbClr val="007B8C"/>
+          </a:solidFill>
+          <a:ln/>
+        </p:spPr>
+        <p:txBody>
+          <a:bodyPr/>
+          <a:lstStyle/>
+          <a:p>
+            <a:endParaRPr lang="en-US"/>
+          </a:p>
+        </p:txBody>
+      </p:sp>
+      <p:sp>
+        <p:nvSpPr>
+          <p:cNvPr id="10" name="Text 7"/>
+          <p:cNvSpPr/>
+          <p:nvPr/>
+        </p:nvSpPr>
+        <p:spPr>
+          <a:xfrm>
+            <a:off x="640080" y="3017520"/>
+            <a:ext cx="3108960" cy="237744"/>
+          </a:xfrm>
+          <a:prstGeom prst="rect">
+            <a:avLst/>
+          </a:prstGeom>
+          <a:noFill/>
+          <a:ln/>
+        </p:spPr>
+        <p:txBody>
+          <a:bodyPr wrap="square" lIns="0" tIns="0" rIns="0" bIns="0" rtlCol="0" anchor="ctr"/>
+          <a:lstStyle/>
+          <a:p>
+            <a:pPr marL="0" indent="0">
+              <a:buNone/>
+            </a:pPr>
+            <a:r>
+              <a:rPr lang="en-US" sz="1100" b="1" dirty="0">
+                <a:solidFill>
+                  <a:srgbClr val="007B8C"/>
+                </a:solidFill>
+                <a:latin typeface="Arial" pitchFamily="34" charset="0"/>
+                <a:ea typeface="Arial" pitchFamily="34" charset="-122"/>
+                <a:cs typeface="Arial" pitchFamily="34" charset="-120"/>
+              </a:rPr>
+              <a:t>WHY TOGETHER</a:t>
+            </a:r>
+            <a:endParaRPr lang="en-US" sz="1100" dirty="0"/>
+          </a:p>
+        </p:txBody>
+      </p:sp>
+      <p:sp>
+        <p:nvSpPr>
+          <p:cNvPr id="11" name="Text 8"/>
+          <p:cNvSpPr/>
+          <p:nvPr/>
+        </p:nvSpPr>
+        <p:spPr>
+          <a:xfrm>
+            <a:off x="640080" y="3273552"/>
+            <a:ext cx="3063240" cy="822960"/>
+          </a:xfrm>
+          <a:prstGeom prst="rect">
+            <a:avLst/>
+          </a:prstGeom>
+          <a:noFill/>
+          <a:ln/>
+        </p:spPr>
+        <p:txBody>
+          <a:bodyPr wrap="square" lIns="0" tIns="0" rIns="0" bIns="0" rtlCol="0" anchor="t"/>
+          <a:lstStyle/>
+          <a:p>
+            <a:pPr marL="0" indent="0">
+              <a:buNone/>
+            </a:pPr>
+            <a:r>
+              <a:rPr lang="en-US" sz="1150" dirty="0">
+                <a:solidFill>
+                  <a:srgbClr val="EEEFF0"/>
+                </a:solidFill>
+                <a:latin typeface="Arial" pitchFamily="34" charset="0"/>
+                <a:ea typeface="Arial" pitchFamily="34" charset="-122"/>
+                <a:cs typeface="Arial" pitchFamily="34" charset="-120"/>
+              </a:rPr>
+              <a:t>#1 (agent tools) and #2 (typed contract) share one schema artifact — build it once per catalog entry, get both a spec and a tool set.</a:t>
+            </a:r>
+            <a:endParaRPr lang="en-US" sz="1150" dirty="0"/>
+          </a:p>
+        </p:txBody>
+      </p:sp>
+      <p:sp>
+        <p:nvSpPr>
+          <p:cNvPr id="12" name="Shape 9"/>
+          <p:cNvSpPr/>
+          <p:nvPr/>
+        </p:nvSpPr>
+        <p:spPr>
+          <a:xfrm>
+            <a:off x="457200" y="4233672"/>
+            <a:ext cx="54864" cy="1042416"/>
+          </a:xfrm>
+          <a:prstGeom prst="rect">
+            <a:avLst/>
+          </a:prstGeom>
+          <a:solidFill>
+            <a:srgbClr val="0098C7"/>
+          </a:solidFill>
+          <a:ln/>
+        </p:spPr>
+        <p:txBody>
+          <a:bodyPr/>
+          <a:lstStyle/>
+          <a:p>
+            <a:endParaRPr lang="en-US"/>
+          </a:p>
+        </p:txBody>
+      </p:sp>
+      <p:sp>
+        <p:nvSpPr>
+          <p:cNvPr id="13" name="Text 10"/>
+          <p:cNvSpPr/>
+          <p:nvPr/>
+        </p:nvSpPr>
+        <p:spPr>
+          <a:xfrm>
+            <a:off x="640080" y="4233672"/>
+            <a:ext cx="3108960" cy="237744"/>
+          </a:xfrm>
+          <a:prstGeom prst="rect">
+            <a:avLst/>
+          </a:prstGeom>
+          <a:noFill/>
+          <a:ln/>
+        </p:spPr>
+        <p:txBody>
+          <a:bodyPr wrap="square" lIns="0" tIns="0" rIns="0" bIns="0" rtlCol="0" anchor="ctr"/>
+          <a:lstStyle/>
+          <a:p>
+            <a:pPr marL="0" indent="0">
+              <a:buNone/>
+            </a:pPr>
+            <a:r>
+              <a:rPr lang="en-US" sz="1100" b="1" dirty="0">
+                <a:solidFill>
+                  <a:srgbClr val="0098C7"/>
+                </a:solidFill>
+                <a:latin typeface="Arial" pitchFamily="34" charset="0"/>
+                <a:ea typeface="Arial" pitchFamily="34" charset="-122"/>
+                <a:cs typeface="Arial" pitchFamily="34" charset="-120"/>
+              </a:rPr>
+              <a:t>WHAT'S NOT HERE</a:t>
+            </a:r>
+            <a:endParaRPr lang="en-US" sz="1100" dirty="0"/>
+          </a:p>
+        </p:txBody>
+      </p:sp>
+      <p:sp>
+        <p:nvSpPr>
+          <p:cNvPr id="14" name="Text 11"/>
+          <p:cNvSpPr/>
+          <p:nvPr/>
+        </p:nvSpPr>
+        <p:spPr>
+          <a:xfrm>
+            <a:off x="640080" y="4489704"/>
+            <a:ext cx="3063240" cy="786384"/>
+          </a:xfrm>
+          <a:prstGeom prst="rect">
+            <a:avLst/>
+          </a:prstGeom>
+          <a:noFill/>
+          <a:ln/>
+        </p:spPr>
+        <p:txBody>
+          <a:bodyPr wrap="square" lIns="0" tIns="0" rIns="0" bIns="0" rtlCol="0" anchor="t"/>
+          <a:lstStyle/>
+          <a:p>
+            <a:pPr marL="0" indent="0">
+              <a:buNone/>
+            </a:pPr>
+            <a:r>
+              <a:rPr lang="en-US" sz="1150" dirty="0">
+                <a:solidFill>
+                  <a:srgbClr val="EEEFF0"/>
+                </a:solidFill>
+                <a:latin typeface="Arial" pitchFamily="34" charset="0"/>
+                <a:ea typeface="Arial" pitchFamily="34" charset="-122"/>
+                <a:cs typeface="Arial" pitchFamily="34" charset="-120"/>
+              </a:rPr>
+              <a:t>Composite-ID resolution as its own service (#3) is on a separate page — held, and not part of this to-do plan.</a:t>
+            </a:r>
+            <a:endParaRPr lang="en-US" sz="1150" dirty="0"/>
+          </a:p>
+        </p:txBody>
+      </p:sp>
+      <p:sp>
+        <p:nvSpPr>
+          <p:cNvPr id="15" name="Shape 12"/>
+          <p:cNvSpPr/>
+          <p:nvPr/>
+        </p:nvSpPr>
+        <p:spPr>
+          <a:xfrm>
+            <a:off x="457200" y="5623560"/>
+            <a:ext cx="3337560" cy="914400"/>
+          </a:xfrm>
+          <a:prstGeom prst="roundRect">
+            <a:avLst>
+              <a:gd name="adj" fmla="val 8000"/>
+            </a:avLst>
+          </a:prstGeom>
+          <a:solidFill>
+            <a:srgbClr val="3B4652"/>
+          </a:solidFill>
+          <a:ln w="12700">
+            <a:solidFill>
+              <a:srgbClr val="0098C7"/>
+            </a:solidFill>
+            <a:prstDash val="solid"/>
+          </a:ln>
+        </p:spPr>
+        <p:txBody>
+          <a:bodyPr/>
+          <a:lstStyle/>
+          <a:p>
+            <a:endParaRPr lang="en-US"/>
+          </a:p>
+        </p:txBody>
+      </p:sp>
+      <p:sp>
+        <p:nvSpPr>
+          <p:cNvPr id="16" name="Text 13"/>
+          <p:cNvSpPr/>
+          <p:nvPr/>
+        </p:nvSpPr>
+        <p:spPr>
+          <a:xfrm>
+            <a:off x="658368" y="5742432"/>
+            <a:ext cx="2971800" cy="685800"/>
+          </a:xfrm>
+          <a:prstGeom prst="rect">
+            <a:avLst/>
+          </a:prstGeom>
+          <a:noFill/>
+          <a:ln/>
+        </p:spPr>
+        <p:txBody>
+          <a:bodyPr wrap="square" lIns="0" tIns="0" rIns="0" bIns="0" rtlCol="0" anchor="t"/>
+          <a:lstStyle/>
+          <a:p>
+            <a:pPr marL="0" indent="0">
+              <a:buNone/>
+            </a:pPr>
+            <a:r>
+              <a:rPr lang="en-US" sz="1050" b="1" dirty="0">
+                <a:solidFill>
+                  <a:srgbClr val="0098C7"/>
+                </a:solidFill>
+                <a:latin typeface="Arial" pitchFamily="34" charset="0"/>
+                <a:ea typeface="Arial" pitchFamily="34" charset="-122"/>
+                <a:cs typeface="Arial" pitchFamily="34" charset="-120"/>
+              </a:rPr>
+              <a:t>STATUS</a:t>
+            </a:r>
+            <a:endParaRPr lang="en-US" sz="1050" dirty="0"/>
+          </a:p>
+          <a:p>
+            <a:pPr marL="0" indent="0">
+              <a:buNone/>
+            </a:pPr>
+            <a:r>
+              <a:rPr lang="en-US" sz="1250" b="1" dirty="0">
+                <a:solidFill>
+                  <a:srgbClr val="FFFFFF"/>
+                </a:solidFill>
+                <a:latin typeface="Arial" pitchFamily="34" charset="0"/>
+                <a:ea typeface="Arial" pitchFamily="34" charset="-122"/>
+                <a:cs typeface="Arial" pitchFamily="34" charset="-120"/>
+              </a:rPr>
+              <a:t>Design — v2 direction agreed, to-do plan below</a:t>
+            </a:r>
+            <a:endParaRPr lang="en-US" sz="1050" dirty="0"/>
+          </a:p>
+        </p:txBody>
+      </p:sp>
+      <p:sp>
+        <p:nvSpPr>
+          <p:cNvPr id="17" name="Text 14"/>
+          <p:cNvSpPr/>
+          <p:nvPr/>
+        </p:nvSpPr>
+        <p:spPr>
+          <a:xfrm>
+            <a:off x="4572000" y="256032"/>
+            <a:ext cx="7159752" cy="365760"/>
+          </a:xfrm>
+          <a:prstGeom prst="rect">
+            <a:avLst/>
+          </a:prstGeom>
+          <a:noFill/>
+          <a:ln/>
+        </p:spPr>
+        <p:txBody>
+          <a:bodyPr wrap="square" lIns="0" tIns="0" rIns="0" bIns="0" rtlCol="0" anchor="ctr"/>
+          <a:lstStyle/>
+          <a:p>
+            <a:pPr marL="0" indent="0">
+              <a:buNone/>
+            </a:pPr>
+            <a:r>
+              <a:rPr lang="en-US" sz="1900" b="1" dirty="0">
+                <a:solidFill>
+                  <a:srgbClr val="005C8A"/>
+                </a:solidFill>
+                <a:latin typeface="Arial" pitchFamily="34" charset="0"/>
+                <a:ea typeface="Arial" pitchFamily="34" charset="-122"/>
+                <a:cs typeface="Arial" pitchFamily="34" charset="-120"/>
+              </a:rPr>
+              <a:t>AGENT-ORIENTED API TRANSITION — V2 TO-DO PLAN</a:t>
+            </a:r>
+            <a:endParaRPr lang="en-US" sz="1900" dirty="0"/>
+          </a:p>
+        </p:txBody>
+      </p:sp>
+      <p:sp>
+        <p:nvSpPr>
+          <p:cNvPr id="18" name="Text 15"/>
+          <p:cNvSpPr/>
+          <p:nvPr/>
+        </p:nvSpPr>
+        <p:spPr>
+          <a:xfrm>
+            <a:off x="4572000" y="694944"/>
+            <a:ext cx="7159752" cy="292608"/>
+          </a:xfrm>
+          <a:prstGeom prst="rect">
+            <a:avLst/>
+          </a:prstGeom>
+          <a:noFill/>
+          <a:ln/>
+        </p:spPr>
+        <p:txBody>
+          <a:bodyPr wrap="square" lIns="0" tIns="0" rIns="0" bIns="0" rtlCol="0" anchor="ctr"/>
+          <a:lstStyle/>
+          <a:p>
+            <a:pPr marL="0" indent="0">
+              <a:buNone/>
+            </a:pPr>
+            <a:r>
+              <a:rPr lang="en-US" sz="1250" b="1" dirty="0">
+                <a:solidFill>
+                  <a:srgbClr val="53565A"/>
+                </a:solidFill>
+                <a:latin typeface="Arial" pitchFamily="34" charset="0"/>
+                <a:ea typeface="Arial" pitchFamily="34" charset="-122"/>
+                <a:cs typeface="Arial" pitchFamily="34" charset="-120"/>
+              </a:rPr>
+              <a:t>Six concrete steps — from today’s SQL-string API to agent-callable tools.</a:t>
+            </a:r>
+            <a:endParaRPr lang="en-US" sz="1250" dirty="0"/>
+          </a:p>
+        </p:txBody>
+      </p:sp>
+      <p:sp>
+        <p:nvSpPr>
+          <p:cNvPr id="19" name="Text 16"/>
+          <p:cNvSpPr/>
+          <p:nvPr/>
+        </p:nvSpPr>
+        <p:spPr>
+          <a:xfrm>
+            <a:off x="4373880" y="6281928"/>
+            <a:ext cx="7159752" cy="292608"/>
+          </a:xfrm>
+          <a:prstGeom prst="rect">
+            <a:avLst/>
+          </a:prstGeom>
+          <a:noFill/>
+          <a:ln/>
+        </p:spPr>
+        <p:txBody>
+          <a:bodyPr wrap="square" lIns="0" tIns="0" rIns="0" bIns="0" rtlCol="0" anchor="ctr"/>
+          <a:lstStyle/>
+          <a:p>
+            <a:pPr marL="0" indent="0">
+              <a:buNone/>
+            </a:pPr>
+            <a:r>
+              <a:rPr lang="en-US" sz="1100" dirty="0">
+                <a:solidFill>
+                  <a:srgbClr val="53565A"/>
+                </a:solidFill>
+                <a:latin typeface="Arial" pitchFamily="34" charset="0"/>
+                <a:ea typeface="Arial" pitchFamily="34" charset="-122"/>
+                <a:cs typeface="Arial" pitchFamily="34" charset="-120"/>
+              </a:rPr>
+              <a:t>Steps 1–3 build the shared schema artifact; 4–6 make it safe and provable before scaling.</a:t>
+            </a:r>
+            <a:endParaRPr lang="en-US" sz="1100" dirty="0"/>
+          </a:p>
+        </p:txBody>
+      </p:sp>
+      <p:sp>
+        <p:nvSpPr>
+          <p:cNvPr id="20" name="Shape 17"/>
+          <p:cNvSpPr/>
+          <p:nvPr/>
+        </p:nvSpPr>
+        <p:spPr>
+          <a:xfrm>
+            <a:off x="4572000" y="960120"/>
+            <a:ext cx="292608" cy="292608"/>
+          </a:xfrm>
+          <a:prstGeom prst="ellipse">
+            <a:avLst/>
+          </a:prstGeom>
+          <a:solidFill>
+            <a:srgbClr val="53565A"/>
+          </a:solidFill>
+          <a:ln/>
+        </p:spPr>
+        <p:txBody>
+          <a:bodyPr/>
+          <a:lstStyle/>
+          <a:p>
+            <a:endParaRPr lang="en-US"/>
+          </a:p>
+        </p:txBody>
+      </p:sp>
+      <p:sp>
+        <p:nvSpPr>
+          <p:cNvPr id="21" name="Text 18"/>
+          <p:cNvSpPr/>
+          <p:nvPr/>
+        </p:nvSpPr>
+        <p:spPr>
+          <a:xfrm>
+            <a:off x="4572000" y="960120"/>
+            <a:ext cx="292608" cy="292608"/>
+          </a:xfrm>
+          <a:prstGeom prst="rect">
+            <a:avLst/>
+          </a:prstGeom>
+          <a:noFill/>
+          <a:ln/>
+        </p:spPr>
+        <p:txBody>
+          <a:bodyPr wrap="square" lIns="0" tIns="0" rIns="0" bIns="0" rtlCol="0" anchor="ctr"/>
+          <a:lstStyle/>
+          <a:p>
+            <a:pPr marL="0" indent="0" algn="ctr">
+              <a:buNone/>
+            </a:pPr>
+            <a:r>
+              <a:rPr lang="en-US" sz="1200" b="1" dirty="0">
+                <a:solidFill>
+                  <a:srgbClr val="FFFFFF"/>
+                </a:solidFill>
+                <a:latin typeface="Arial" pitchFamily="34" charset="0"/>
+                <a:ea typeface="Arial" pitchFamily="34" charset="-122"/>
+                <a:cs typeface="Arial" pitchFamily="34" charset="-120"/>
+              </a:rPr>
+              <a:t>1</a:t>
+            </a:r>
+            <a:endParaRPr lang="en-US" sz="1200" dirty="0"/>
+          </a:p>
+        </p:txBody>
+      </p:sp>
+      <p:sp>
+        <p:nvSpPr>
+          <p:cNvPr id="22" name="Text 19"/>
+          <p:cNvSpPr/>
+          <p:nvPr/>
+        </p:nvSpPr>
+        <p:spPr>
+          <a:xfrm>
+            <a:off x="4956048" y="941832"/>
+            <a:ext cx="4206240" cy="292608"/>
+          </a:xfrm>
+          <a:prstGeom prst="rect">
+            <a:avLst/>
+          </a:prstGeom>
+          <a:noFill/>
+          <a:ln/>
+        </p:spPr>
+        <p:txBody>
+          <a:bodyPr wrap="square" lIns="0" tIns="0" rIns="0" bIns="0" rtlCol="0" anchor="ctr"/>
+          <a:lstStyle/>
+          <a:p>
+            <a:pPr marL="0" indent="0" algn="l">
+              <a:buNone/>
+            </a:pPr>
+            <a:r>
+              <a:rPr lang="en-US" sz="1200" b="1" dirty="0">
+                <a:solidFill>
+                  <a:srgbClr val="005C8A"/>
+                </a:solidFill>
+                <a:latin typeface="Arial" pitchFamily="34" charset="0"/>
+                <a:ea typeface="Arial" pitchFamily="34" charset="-122"/>
+                <a:cs typeface="Arial" pitchFamily="34" charset="-120"/>
+              </a:rPr>
+              <a:t>① Define Typed Schema</a:t>
+            </a:r>
+            <a:endParaRPr lang="en-US" sz="1200" dirty="0"/>
+          </a:p>
+        </p:txBody>
+      </p:sp>
+      <p:sp>
+        <p:nvSpPr>
+          <p:cNvPr id="23" name="Text 20"/>
+          <p:cNvSpPr/>
+          <p:nvPr/>
+        </p:nvSpPr>
+        <p:spPr>
+          <a:xfrm>
+            <a:off x="9720072" y="941832"/>
+            <a:ext cx="2011680" cy="292608"/>
+          </a:xfrm>
+          <a:prstGeom prst="rect">
+            <a:avLst/>
+          </a:prstGeom>
+          <a:noFill/>
+          <a:ln/>
+        </p:spPr>
+        <p:txBody>
+          <a:bodyPr wrap="square" lIns="0" tIns="0" rIns="0" bIns="0" rtlCol="0" anchor="ctr"/>
+          <a:lstStyle/>
+          <a:p>
+            <a:pPr marL="0" indent="0" algn="r">
+              <a:buNone/>
+            </a:pPr>
+            <a:r>
+              <a:rPr lang="en-US" sz="950" i="1" dirty="0">
+                <a:solidFill>
+                  <a:srgbClr val="53565A"/>
+                </a:solidFill>
+                <a:latin typeface="Arial" pitchFamily="34" charset="0"/>
+                <a:ea typeface="Arial" pitchFamily="34" charset="-122"/>
+                <a:cs typeface="Arial" pitchFamily="34" charset="-120"/>
+              </a:rPr>
+              <a:t>Foundation</a:t>
+            </a:r>
+            <a:endParaRPr lang="en-US" sz="950" dirty="0"/>
+          </a:p>
+        </p:txBody>
+      </p:sp>
+      <p:sp>
+        <p:nvSpPr>
+          <p:cNvPr id="24" name="Shape 21"/>
+          <p:cNvSpPr/>
+          <p:nvPr/>
+        </p:nvSpPr>
+        <p:spPr>
+          <a:xfrm>
+            <a:off x="4572000" y="1271016"/>
+            <a:ext cx="7159752" cy="457200"/>
+          </a:xfrm>
+          <a:prstGeom prst="roundRect">
+            <a:avLst>
+              <a:gd name="adj" fmla="val 10000"/>
+            </a:avLst>
+          </a:prstGeom>
+          <a:solidFill>
+            <a:srgbClr val="FFFFFF"/>
+          </a:solidFill>
+          <a:ln w="9525">
+            <a:solidFill>
+              <a:srgbClr val="EEEFF0"/>
+            </a:solidFill>
+            <a:prstDash val="solid"/>
+          </a:ln>
+        </p:spPr>
+        <p:txBody>
+          <a:bodyPr/>
+          <a:lstStyle/>
+          <a:p>
+            <a:endParaRPr lang="en-US"/>
+          </a:p>
+        </p:txBody>
+      </p:sp>
+      <p:sp>
+        <p:nvSpPr>
+          <p:cNvPr id="25" name="Text 22"/>
+          <p:cNvSpPr/>
+          <p:nvPr/>
+        </p:nvSpPr>
+        <p:spPr>
+          <a:xfrm>
+            <a:off x="4709160" y="1271016"/>
+            <a:ext cx="6885432" cy="457200"/>
+          </a:xfrm>
+          <a:prstGeom prst="rect">
+            <a:avLst/>
+          </a:prstGeom>
+          <a:noFill/>
+          <a:ln/>
+        </p:spPr>
+        <p:txBody>
+          <a:bodyPr wrap="square" lIns="0" tIns="0" rIns="0" bIns="0" rtlCol="0" anchor="ctr"/>
+          <a:lstStyle/>
+          <a:p>
+            <a:pPr marL="0" indent="0" algn="l">
+              <a:buNone/>
+            </a:pPr>
+            <a:r>
+              <a:rPr lang="en-US" sz="900" dirty="0">
+                <a:solidFill>
+                  <a:srgbClr val="3B4652"/>
+                </a:solidFill>
+                <a:latin typeface="Arial" pitchFamily="34" charset="0"/>
+                <a:ea typeface="Arial" pitchFamily="34" charset="-122"/>
+                <a:cs typeface="Arial" pitchFamily="34" charset="-120"/>
+              </a:rPr>
+              <a:t>Per catalog entry: parameters, types, valid ranges — already funded by v1’s catalog-curation work (§6), not new labor.</a:t>
+            </a:r>
+            <a:endParaRPr lang="en-US" sz="900" dirty="0"/>
+          </a:p>
+        </p:txBody>
+      </p:sp>
+      <p:sp>
+        <p:nvSpPr>
+          <p:cNvPr id="26" name="Text 23"/>
+          <p:cNvSpPr/>
+          <p:nvPr/>
+        </p:nvSpPr>
+        <p:spPr>
+          <a:xfrm>
+            <a:off x="4572000" y="1737360"/>
+            <a:ext cx="292608" cy="128016"/>
+          </a:xfrm>
+          <a:prstGeom prst="rect">
+            <a:avLst/>
+          </a:prstGeom>
+          <a:noFill/>
+          <a:ln/>
+        </p:spPr>
+        <p:txBody>
+          <a:bodyPr wrap="square" lIns="0" tIns="0" rIns="0" bIns="0" rtlCol="0" anchor="ctr"/>
+          <a:lstStyle/>
+          <a:p>
+            <a:pPr marL="0" indent="0" algn="ctr">
+              <a:buNone/>
+            </a:pPr>
+            <a:r>
+              <a:rPr lang="en-US" sz="1100" b="1" dirty="0">
+                <a:solidFill>
+                  <a:srgbClr val="53565A"/>
+                </a:solidFill>
+                <a:latin typeface="Arial" pitchFamily="34" charset="0"/>
+                <a:ea typeface="Arial" pitchFamily="34" charset="-122"/>
+                <a:cs typeface="Arial" pitchFamily="34" charset="-120"/>
+              </a:rPr>
+              <a:t>↓</a:t>
+            </a:r>
+            <a:endParaRPr lang="en-US" sz="1100" dirty="0"/>
+          </a:p>
+        </p:txBody>
+      </p:sp>
+      <p:sp>
+        <p:nvSpPr>
+          <p:cNvPr id="27" name="Shape 24"/>
+          <p:cNvSpPr/>
+          <p:nvPr/>
+        </p:nvSpPr>
+        <p:spPr>
+          <a:xfrm>
+            <a:off x="4572000" y="1847088"/>
+            <a:ext cx="292608" cy="292608"/>
+          </a:xfrm>
+          <a:prstGeom prst="ellipse">
+            <a:avLst/>
+          </a:prstGeom>
+          <a:solidFill>
+            <a:srgbClr val="0098C7"/>
+          </a:solidFill>
+          <a:ln/>
+        </p:spPr>
+        <p:txBody>
+          <a:bodyPr/>
+          <a:lstStyle/>
+          <a:p>
+            <a:endParaRPr lang="en-US"/>
+          </a:p>
+        </p:txBody>
+      </p:sp>
+      <p:sp>
+        <p:nvSpPr>
+          <p:cNvPr id="28" name="Text 25"/>
+          <p:cNvSpPr/>
+          <p:nvPr/>
+        </p:nvSpPr>
+        <p:spPr>
+          <a:xfrm>
+            <a:off x="4572000" y="1847088"/>
+            <a:ext cx="292608" cy="292608"/>
+          </a:xfrm>
+          <a:prstGeom prst="rect">
+            <a:avLst/>
+          </a:prstGeom>
+          <a:noFill/>
+          <a:ln/>
+        </p:spPr>
+        <p:txBody>
+          <a:bodyPr wrap="square" lIns="0" tIns="0" rIns="0" bIns="0" rtlCol="0" anchor="ctr"/>
+          <a:lstStyle/>
+          <a:p>
+            <a:pPr marL="0" indent="0" algn="ctr">
+              <a:buNone/>
+            </a:pPr>
+            <a:r>
+              <a:rPr lang="en-US" sz="1200" b="1" dirty="0">
+                <a:solidFill>
+                  <a:srgbClr val="FFFFFF"/>
+                </a:solidFill>
+                <a:latin typeface="Arial" pitchFamily="34" charset="0"/>
+                <a:ea typeface="Arial" pitchFamily="34" charset="-122"/>
+                <a:cs typeface="Arial" pitchFamily="34" charset="-120"/>
+              </a:rPr>
+              <a:t>2</a:t>
+            </a:r>
+            <a:endParaRPr lang="en-US" sz="1200" dirty="0"/>
+          </a:p>
+        </p:txBody>
+      </p:sp>
+      <p:sp>
+        <p:nvSpPr>
+          <p:cNvPr id="29" name="Text 26"/>
+          <p:cNvSpPr/>
+          <p:nvPr/>
+        </p:nvSpPr>
+        <p:spPr>
+          <a:xfrm>
+            <a:off x="4956048" y="1828800"/>
+            <a:ext cx="4206240" cy="292608"/>
+          </a:xfrm>
+          <a:prstGeom prst="rect">
+            <a:avLst/>
+          </a:prstGeom>
+          <a:noFill/>
+          <a:ln/>
+        </p:spPr>
+        <p:txBody>
+          <a:bodyPr wrap="square" lIns="0" tIns="0" rIns="0" bIns="0" rtlCol="0" anchor="ctr"/>
+          <a:lstStyle/>
+          <a:p>
+            <a:pPr marL="0" indent="0" algn="l">
+              <a:buNone/>
+            </a:pPr>
+            <a:r>
+              <a:rPr lang="en-US" sz="1200" b="1" dirty="0">
+                <a:solidFill>
+                  <a:srgbClr val="0098C7"/>
+                </a:solidFill>
+                <a:latin typeface="Arial" pitchFamily="34" charset="0"/>
+                <a:ea typeface="Arial" pitchFamily="34" charset="-122"/>
+                <a:cs typeface="Arial" pitchFamily="34" charset="-120"/>
+              </a:rPr>
+              <a:t>② Publish OpenAPI Contract (#2)</a:t>
+            </a:r>
+            <a:endParaRPr lang="en-US" sz="1200" dirty="0"/>
+          </a:p>
+        </p:txBody>
+      </p:sp>
+      <p:sp>
+        <p:nvSpPr>
+          <p:cNvPr id="30" name="Text 27"/>
+          <p:cNvSpPr/>
+          <p:nvPr/>
+        </p:nvSpPr>
+        <p:spPr>
+          <a:xfrm>
+            <a:off x="9720072" y="1828800"/>
+            <a:ext cx="2011680" cy="292608"/>
+          </a:xfrm>
+          <a:prstGeom prst="rect">
+            <a:avLst/>
+          </a:prstGeom>
+          <a:noFill/>
+          <a:ln/>
+        </p:spPr>
+        <p:txBody>
+          <a:bodyPr wrap="square" lIns="0" tIns="0" rIns="0" bIns="0" rtlCol="0" anchor="ctr"/>
+          <a:lstStyle/>
+          <a:p>
+            <a:pPr marL="0" indent="0" algn="r">
+              <a:buNone/>
+            </a:pPr>
+            <a:r>
+              <a:rPr lang="en-US" sz="950" i="1" dirty="0">
+                <a:solidFill>
+                  <a:srgbClr val="53565A"/>
+                </a:solidFill>
+                <a:latin typeface="Arial" pitchFamily="34" charset="0"/>
+                <a:ea typeface="Arial" pitchFamily="34" charset="-122"/>
+                <a:cs typeface="Arial" pitchFamily="34" charset="-120"/>
+              </a:rPr>
+              <a:t>Contract</a:t>
+            </a:r>
+            <a:endParaRPr lang="en-US" sz="950" dirty="0"/>
+          </a:p>
+        </p:txBody>
+      </p:sp>
+      <p:sp>
+        <p:nvSpPr>
+          <p:cNvPr id="31" name="Shape 28"/>
+          <p:cNvSpPr/>
+          <p:nvPr/>
+        </p:nvSpPr>
+        <p:spPr>
+          <a:xfrm>
+            <a:off x="4572000" y="2157984"/>
+            <a:ext cx="7159752" cy="457200"/>
+          </a:xfrm>
+          <a:prstGeom prst="roundRect">
+            <a:avLst>
+              <a:gd name="adj" fmla="val 10000"/>
+            </a:avLst>
+          </a:prstGeom>
+          <a:solidFill>
+            <a:srgbClr val="FFFFFF"/>
+          </a:solidFill>
+          <a:ln w="9525">
+            <a:solidFill>
+              <a:srgbClr val="EEEFF0"/>
+            </a:solidFill>
+            <a:prstDash val="solid"/>
+          </a:ln>
+        </p:spPr>
+        <p:txBody>
+          <a:bodyPr/>
+          <a:lstStyle/>
+          <a:p>
+            <a:endParaRPr lang="en-US"/>
+          </a:p>
+        </p:txBody>
+      </p:sp>
+      <p:sp>
+        <p:nvSpPr>
+          <p:cNvPr id="32" name="Text 29"/>
+          <p:cNvSpPr/>
+          <p:nvPr/>
+        </p:nvSpPr>
+        <p:spPr>
+          <a:xfrm>
+            <a:off x="4709160" y="2157984"/>
+            <a:ext cx="6885432" cy="457200"/>
+          </a:xfrm>
+          <a:prstGeom prst="rect">
+            <a:avLst/>
+          </a:prstGeom>
+          <a:noFill/>
+          <a:ln/>
+        </p:spPr>
+        <p:txBody>
+          <a:bodyPr wrap="square" lIns="0" tIns="0" rIns="0" bIns="0" rtlCol="0" anchor="ctr"/>
+          <a:lstStyle/>
+          <a:p>
+            <a:pPr marL="0" indent="0" algn="l">
+              <a:buNone/>
+            </a:pPr>
+            <a:r>
+              <a:rPr lang="en-US" sz="900" dirty="0">
+                <a:solidFill>
+                  <a:srgbClr val="3B4652"/>
+                </a:solidFill>
+                <a:latin typeface="Arial" pitchFamily="34" charset="0"/>
+                <a:ea typeface="Arial" pitchFamily="34" charset="-122"/>
+                <a:cs typeface="Arial" pitchFamily="34" charset="-120"/>
+              </a:rPr>
+              <a:t>One machine-readable spec per domain — the typed request format that replaces the SQL-style string as the public contract.</a:t>
+            </a:r>
+            <a:endParaRPr lang="en-US" sz="900" dirty="0"/>
+          </a:p>
+        </p:txBody>
+      </p:sp>
+      <p:sp>
+        <p:nvSpPr>
+          <p:cNvPr id="33" name="Text 30"/>
+          <p:cNvSpPr/>
+          <p:nvPr/>
+        </p:nvSpPr>
+        <p:spPr>
+          <a:xfrm>
+            <a:off x="4572000" y="2624328"/>
+            <a:ext cx="292608" cy="128016"/>
+          </a:xfrm>
+          <a:prstGeom prst="rect">
+            <a:avLst/>
+          </a:prstGeom>
+          <a:noFill/>
+          <a:ln/>
+        </p:spPr>
+        <p:txBody>
+          <a:bodyPr wrap="square" lIns="0" tIns="0" rIns="0" bIns="0" rtlCol="0" anchor="ctr"/>
+          <a:lstStyle/>
+          <a:p>
+            <a:pPr marL="0" indent="0" algn="ctr">
+              <a:buNone/>
+            </a:pPr>
+            <a:r>
+              <a:rPr lang="en-US" sz="1100" b="1" dirty="0">
+                <a:solidFill>
+                  <a:srgbClr val="53565A"/>
+                </a:solidFill>
+                <a:latin typeface="Arial" pitchFamily="34" charset="0"/>
+                <a:ea typeface="Arial" pitchFamily="34" charset="-122"/>
+                <a:cs typeface="Arial" pitchFamily="34" charset="-120"/>
+              </a:rPr>
+              <a:t>↓</a:t>
+            </a:r>
+            <a:endParaRPr lang="en-US" sz="1100" dirty="0"/>
+          </a:p>
+        </p:txBody>
+      </p:sp>
+      <p:sp>
+        <p:nvSpPr>
+          <p:cNvPr id="34" name="Shape 31"/>
+          <p:cNvSpPr/>
+          <p:nvPr/>
+        </p:nvSpPr>
+        <p:spPr>
+          <a:xfrm>
+            <a:off x="4572000" y="2734056"/>
+            <a:ext cx="292608" cy="292608"/>
+          </a:xfrm>
+          <a:prstGeom prst="ellipse">
+            <a:avLst/>
+          </a:prstGeom>
+          <a:solidFill>
+            <a:srgbClr val="0098C7"/>
+          </a:solidFill>
+          <a:ln/>
+        </p:spPr>
+        <p:txBody>
+          <a:bodyPr/>
+          <a:lstStyle/>
+          <a:p>
+            <a:endParaRPr lang="en-US"/>
+          </a:p>
+        </p:txBody>
+      </p:sp>
+      <p:sp>
+        <p:nvSpPr>
+          <p:cNvPr id="35" name="Text 32"/>
+          <p:cNvSpPr/>
+          <p:nvPr/>
+        </p:nvSpPr>
+        <p:spPr>
+          <a:xfrm>
+            <a:off x="4572000" y="2734056"/>
+            <a:ext cx="292608" cy="292608"/>
+          </a:xfrm>
+          <a:prstGeom prst="rect">
+            <a:avLst/>
+          </a:prstGeom>
+          <a:noFill/>
+          <a:ln/>
+        </p:spPr>
+        <p:txBody>
+          <a:bodyPr wrap="square" lIns="0" tIns="0" rIns="0" bIns="0" rtlCol="0" anchor="ctr"/>
+          <a:lstStyle/>
+          <a:p>
+            <a:pPr marL="0" indent="0" algn="ctr">
+              <a:buNone/>
+            </a:pPr>
+            <a:r>
+              <a:rPr lang="en-US" sz="1200" b="1" dirty="0">
+                <a:solidFill>
+                  <a:srgbClr val="FFFFFF"/>
+                </a:solidFill>
+                <a:latin typeface="Arial" pitchFamily="34" charset="0"/>
+                <a:ea typeface="Arial" pitchFamily="34" charset="-122"/>
+                <a:cs typeface="Arial" pitchFamily="34" charset="-120"/>
+              </a:rPr>
+              <a:t>3</a:t>
+            </a:r>
+            <a:endParaRPr lang="en-US" sz="1200" dirty="0"/>
+          </a:p>
+        </p:txBody>
+      </p:sp>
+      <p:sp>
+        <p:nvSpPr>
+          <p:cNvPr id="36" name="Text 33"/>
+          <p:cNvSpPr/>
+          <p:nvPr/>
+        </p:nvSpPr>
+        <p:spPr>
+          <a:xfrm>
+            <a:off x="4956048" y="2715768"/>
+            <a:ext cx="4206240" cy="292608"/>
+          </a:xfrm>
+          <a:prstGeom prst="rect">
+            <a:avLst/>
+          </a:prstGeom>
+          <a:noFill/>
+          <a:ln/>
+        </p:spPr>
+        <p:txBody>
+          <a:bodyPr wrap="square" lIns="0" tIns="0" rIns="0" bIns="0" rtlCol="0" anchor="ctr"/>
+          <a:lstStyle/>
+          <a:p>
+            <a:pPr marL="0" indent="0" algn="l">
+              <a:buNone/>
+            </a:pPr>
+            <a:r>
+              <a:rPr lang="en-US" sz="1200" b="1" dirty="0">
+                <a:solidFill>
+                  <a:srgbClr val="0098C7"/>
+                </a:solidFill>
+                <a:latin typeface="Arial" pitchFamily="34" charset="0"/>
+                <a:ea typeface="Arial" pitchFamily="34" charset="-122"/>
+                <a:cs typeface="Arial" pitchFamily="34" charset="-120"/>
+              </a:rPr>
+              <a:t>③ Generate Agent Tools (#1)</a:t>
+            </a:r>
+            <a:endParaRPr lang="en-US" sz="1200" dirty="0"/>
+          </a:p>
+        </p:txBody>
+      </p:sp>
+      <p:sp>
+        <p:nvSpPr>
+          <p:cNvPr id="37" name="Text 34"/>
+          <p:cNvSpPr/>
+          <p:nvPr/>
+        </p:nvSpPr>
+        <p:spPr>
+          <a:xfrm>
+            <a:off x="9720072" y="2715768"/>
+            <a:ext cx="2011680" cy="292608"/>
+          </a:xfrm>
+          <a:prstGeom prst="rect">
+            <a:avLst/>
+          </a:prstGeom>
+          <a:noFill/>
+          <a:ln/>
+        </p:spPr>
+        <p:txBody>
+          <a:bodyPr wrap="square" lIns="0" tIns="0" rIns="0" bIns="0" rtlCol="0" anchor="ctr"/>
+          <a:lstStyle/>
+          <a:p>
+            <a:pPr marL="0" indent="0" algn="r">
+              <a:buNone/>
+            </a:pPr>
+            <a:r>
+              <a:rPr lang="en-US" sz="950" i="1" dirty="0">
+                <a:solidFill>
+                  <a:srgbClr val="53565A"/>
+                </a:solidFill>
+                <a:latin typeface="Arial" pitchFamily="34" charset="0"/>
+                <a:ea typeface="Arial" pitchFamily="34" charset="-122"/>
+                <a:cs typeface="Arial" pitchFamily="34" charset="-120"/>
+              </a:rPr>
+              <a:t>Tooling</a:t>
+            </a:r>
+            <a:endParaRPr lang="en-US" sz="950" dirty="0"/>
+          </a:p>
+        </p:txBody>
+      </p:sp>
+      <p:sp>
+        <p:nvSpPr>
+          <p:cNvPr id="38" name="Shape 35"/>
+          <p:cNvSpPr/>
+          <p:nvPr/>
+        </p:nvSpPr>
+        <p:spPr>
+          <a:xfrm>
+            <a:off x="4572000" y="3044952"/>
+            <a:ext cx="7159752" cy="457200"/>
+          </a:xfrm>
+          <a:prstGeom prst="roundRect">
+            <a:avLst>
+              <a:gd name="adj" fmla="val 10000"/>
+            </a:avLst>
+          </a:prstGeom>
+          <a:solidFill>
+            <a:srgbClr val="FFFFFF"/>
+          </a:solidFill>
+          <a:ln w="9525">
+            <a:solidFill>
+              <a:srgbClr val="EEEFF0"/>
+            </a:solidFill>
+            <a:prstDash val="solid"/>
+          </a:ln>
+        </p:spPr>
+        <p:txBody>
+          <a:bodyPr/>
+          <a:lstStyle/>
+          <a:p>
+            <a:endParaRPr lang="en-US"/>
+          </a:p>
+        </p:txBody>
+      </p:sp>
+      <p:sp>
+        <p:nvSpPr>
+          <p:cNvPr id="39" name="Text 36"/>
+          <p:cNvSpPr/>
+          <p:nvPr/>
+        </p:nvSpPr>
+        <p:spPr>
+          <a:xfrm>
+            <a:off x="4709160" y="3044952"/>
+            <a:ext cx="6885432" cy="457200"/>
+          </a:xfrm>
+          <a:prstGeom prst="rect">
+            <a:avLst/>
+          </a:prstGeom>
+          <a:noFill/>
+          <a:ln/>
+        </p:spPr>
+        <p:txBody>
+          <a:bodyPr wrap="square" lIns="0" tIns="0" rIns="0" bIns="0" rtlCol="0" anchor="ctr"/>
+          <a:lstStyle/>
+          <a:p>
+            <a:pPr marL="0" indent="0" algn="l">
+              <a:buNone/>
+            </a:pPr>
+            <a:r>
+              <a:rPr lang="en-US" sz="900" dirty="0">
+                <a:solidFill>
+                  <a:srgbClr val="3B4652"/>
+                </a:solidFill>
+                <a:latin typeface="Arial" pitchFamily="34" charset="0"/>
+                <a:ea typeface="Arial" pitchFamily="34" charset="-122"/>
+                <a:cs typeface="Arial" pitchFamily="34" charset="-120"/>
+              </a:rPr>
+              <a:t>Callable tool definitions generated from the spec — named, typed, discoverable by any agent, not hand-built per entry.</a:t>
+            </a:r>
+            <a:endParaRPr lang="en-US" sz="900" dirty="0"/>
+          </a:p>
+        </p:txBody>
+      </p:sp>
+      <p:sp>
+        <p:nvSpPr>
+          <p:cNvPr id="40" name="Text 37"/>
+          <p:cNvSpPr/>
+          <p:nvPr/>
+        </p:nvSpPr>
+        <p:spPr>
+          <a:xfrm>
+            <a:off x="4572000" y="3511296"/>
+            <a:ext cx="292608" cy="128016"/>
+          </a:xfrm>
+          <a:prstGeom prst="rect">
+            <a:avLst/>
+          </a:prstGeom>
+          <a:noFill/>
+          <a:ln/>
+        </p:spPr>
+        <p:txBody>
+          <a:bodyPr wrap="square" lIns="0" tIns="0" rIns="0" bIns="0" rtlCol="0" anchor="ctr"/>
+          <a:lstStyle/>
+          <a:p>
+            <a:pPr marL="0" indent="0" algn="ctr">
+              <a:buNone/>
+            </a:pPr>
+            <a:r>
+              <a:rPr lang="en-US" sz="1100" b="1" dirty="0">
+                <a:solidFill>
+                  <a:srgbClr val="53565A"/>
+                </a:solidFill>
+                <a:latin typeface="Arial" pitchFamily="34" charset="0"/>
+                <a:ea typeface="Arial" pitchFamily="34" charset="-122"/>
+                <a:cs typeface="Arial" pitchFamily="34" charset="-120"/>
+              </a:rPr>
+              <a:t>↓</a:t>
+            </a:r>
+            <a:endParaRPr lang="en-US" sz="1100" dirty="0"/>
+          </a:p>
+        </p:txBody>
+      </p:sp>
+      <p:sp>
+        <p:nvSpPr>
+          <p:cNvPr id="41" name="Shape 38"/>
+          <p:cNvSpPr/>
+          <p:nvPr/>
+        </p:nvSpPr>
+        <p:spPr>
+          <a:xfrm>
+            <a:off x="4572000" y="3621024"/>
+            <a:ext cx="292608" cy="292608"/>
+          </a:xfrm>
+          <a:prstGeom prst="ellipse">
+            <a:avLst/>
+          </a:prstGeom>
+          <a:solidFill>
+            <a:srgbClr val="0098C7"/>
+          </a:solidFill>
+          <a:ln/>
+        </p:spPr>
+        <p:txBody>
+          <a:bodyPr/>
+          <a:lstStyle/>
+          <a:p>
+            <a:endParaRPr lang="en-US"/>
+          </a:p>
+        </p:txBody>
+      </p:sp>
+      <p:sp>
+        <p:nvSpPr>
+          <p:cNvPr id="42" name="Text 39"/>
+          <p:cNvSpPr/>
+          <p:nvPr/>
+        </p:nvSpPr>
+        <p:spPr>
+          <a:xfrm>
+            <a:off x="4572000" y="3621024"/>
+            <a:ext cx="292608" cy="292608"/>
+          </a:xfrm>
+          <a:prstGeom prst="rect">
+            <a:avLst/>
+          </a:prstGeom>
+          <a:noFill/>
+          <a:ln/>
+        </p:spPr>
+        <p:txBody>
+          <a:bodyPr wrap="square" lIns="0" tIns="0" rIns="0" bIns="0" rtlCol="0" anchor="ctr"/>
+          <a:lstStyle/>
+          <a:p>
+            <a:pPr marL="0" indent="0" algn="ctr">
+              <a:buNone/>
+            </a:pPr>
+            <a:r>
+              <a:rPr lang="en-US" sz="1200" b="1" dirty="0">
+                <a:solidFill>
+                  <a:srgbClr val="FFFFFF"/>
+                </a:solidFill>
+                <a:latin typeface="Arial" pitchFamily="34" charset="0"/>
+                <a:ea typeface="Arial" pitchFamily="34" charset="-122"/>
+                <a:cs typeface="Arial" pitchFamily="34" charset="-120"/>
+              </a:rPr>
+              <a:t>4</a:t>
+            </a:r>
+            <a:endParaRPr lang="en-US" sz="1200" dirty="0"/>
+          </a:p>
+        </p:txBody>
+      </p:sp>
+      <p:sp>
+        <p:nvSpPr>
+          <p:cNvPr id="43" name="Text 40"/>
+          <p:cNvSpPr/>
+          <p:nvPr/>
+        </p:nvSpPr>
+        <p:spPr>
+          <a:xfrm>
+            <a:off x="4956048" y="3602736"/>
+            <a:ext cx="4206240" cy="292608"/>
+          </a:xfrm>
+          <a:prstGeom prst="rect">
+            <a:avLst/>
+          </a:prstGeom>
+          <a:noFill/>
+          <a:ln/>
+        </p:spPr>
+        <p:txBody>
+          <a:bodyPr wrap="square" lIns="0" tIns="0" rIns="0" bIns="0" rtlCol="0" anchor="ctr"/>
+          <a:lstStyle/>
+          <a:p>
+            <a:pPr marL="0" indent="0" algn="l">
+              <a:buNone/>
+            </a:pPr>
+            <a:r>
+              <a:rPr lang="en-US" sz="1200" b="1" dirty="0">
+                <a:solidFill>
+                  <a:srgbClr val="0098C7"/>
+                </a:solidFill>
+                <a:latin typeface="Arial" pitchFamily="34" charset="0"/>
+                <a:ea typeface="Arial" pitchFamily="34" charset="-122"/>
+                <a:cs typeface="Arial" pitchFamily="34" charset="-120"/>
+              </a:rPr>
+              <a:t>④ Wrap the Confirm Gate</a:t>
+            </a:r>
+            <a:endParaRPr lang="en-US" sz="1200" dirty="0"/>
+          </a:p>
+        </p:txBody>
+      </p:sp>
+      <p:sp>
+        <p:nvSpPr>
+          <p:cNvPr id="44" name="Text 41"/>
+          <p:cNvSpPr/>
+          <p:nvPr/>
+        </p:nvSpPr>
+        <p:spPr>
+          <a:xfrm>
+            <a:off x="9720072" y="3602736"/>
+            <a:ext cx="2011680" cy="292608"/>
+          </a:xfrm>
+          <a:prstGeom prst="rect">
+            <a:avLst/>
+          </a:prstGeom>
+          <a:noFill/>
+          <a:ln/>
+        </p:spPr>
+        <p:txBody>
+          <a:bodyPr wrap="square" lIns="0" tIns="0" rIns="0" bIns="0" rtlCol="0" anchor="ctr"/>
+          <a:lstStyle/>
+          <a:p>
+            <a:pPr marL="0" indent="0" algn="r">
+              <a:buNone/>
+            </a:pPr>
+            <a:r>
+              <a:rPr lang="en-US" sz="950" i="1" dirty="0">
+                <a:solidFill>
+                  <a:srgbClr val="53565A"/>
+                </a:solidFill>
+                <a:latin typeface="Arial" pitchFamily="34" charset="0"/>
+                <a:ea typeface="Arial" pitchFamily="34" charset="-122"/>
+                <a:cs typeface="Arial" pitchFamily="34" charset="-120"/>
+              </a:rPr>
+              <a:t>Safety</a:t>
+            </a:r>
+            <a:endParaRPr lang="en-US" sz="950" dirty="0"/>
+          </a:p>
+        </p:txBody>
+      </p:sp>
+      <p:sp>
+        <p:nvSpPr>
+          <p:cNvPr id="45" name="Shape 42"/>
+          <p:cNvSpPr/>
+          <p:nvPr/>
+        </p:nvSpPr>
+        <p:spPr>
+          <a:xfrm>
+            <a:off x="4572000" y="3931920"/>
+            <a:ext cx="7159752" cy="457200"/>
+          </a:xfrm>
+          <a:prstGeom prst="roundRect">
+            <a:avLst>
+              <a:gd name="adj" fmla="val 10000"/>
+            </a:avLst>
+          </a:prstGeom>
+          <a:solidFill>
+            <a:srgbClr val="FFFFFF"/>
+          </a:solidFill>
+          <a:ln w="9525">
+            <a:solidFill>
+              <a:srgbClr val="EEEFF0"/>
+            </a:solidFill>
+            <a:prstDash val="solid"/>
+          </a:ln>
+        </p:spPr>
+        <p:txBody>
+          <a:bodyPr/>
+          <a:lstStyle/>
+          <a:p>
+            <a:endParaRPr lang="en-US"/>
+          </a:p>
+        </p:txBody>
+      </p:sp>
+      <p:sp>
+        <p:nvSpPr>
+          <p:cNvPr id="46" name="Text 43"/>
+          <p:cNvSpPr/>
+          <p:nvPr/>
+        </p:nvSpPr>
+        <p:spPr>
+          <a:xfrm>
+            <a:off x="4709160" y="3931920"/>
+            <a:ext cx="6885432" cy="457200"/>
+          </a:xfrm>
+          <a:prstGeom prst="rect">
+            <a:avLst/>
+          </a:prstGeom>
+          <a:noFill/>
+          <a:ln/>
+        </p:spPr>
+        <p:txBody>
+          <a:bodyPr wrap="square" lIns="0" tIns="0" rIns="0" bIns="0" rtlCol="0" anchor="ctr"/>
+          <a:lstStyle/>
+          <a:p>
+            <a:pPr marL="0" indent="0" algn="l">
+              <a:buNone/>
+            </a:pPr>
+            <a:r>
+              <a:rPr lang="en-US" sz="900" dirty="0">
+                <a:solidFill>
+                  <a:srgbClr val="3B4652"/>
+                </a:solidFill>
+                <a:latin typeface="Arial" pitchFamily="34" charset="0"/>
+                <a:ea typeface="Arial" pitchFamily="34" charset="-122"/>
+                <a:cs typeface="Arial" pitchFamily="34" charset="-120"/>
+              </a:rPr>
+              <a:t>Sandbox-cap → confirm becomes a two-call contract: preview returns a token, execute requires it — same mandatory gate, agent-callable.</a:t>
+            </a:r>
+            <a:endParaRPr lang="en-US" sz="900" dirty="0"/>
+          </a:p>
+        </p:txBody>
+      </p:sp>
+      <p:sp>
+        <p:nvSpPr>
+          <p:cNvPr id="47" name="Text 44"/>
+          <p:cNvSpPr/>
+          <p:nvPr/>
+        </p:nvSpPr>
+        <p:spPr>
+          <a:xfrm>
+            <a:off x="4572000" y="4398264"/>
+            <a:ext cx="292608" cy="128016"/>
+          </a:xfrm>
+          <a:prstGeom prst="rect">
+            <a:avLst/>
+          </a:prstGeom>
+          <a:noFill/>
+          <a:ln/>
+        </p:spPr>
+        <p:txBody>
+          <a:bodyPr wrap="square" lIns="0" tIns="0" rIns="0" bIns="0" rtlCol="0" anchor="ctr"/>
+          <a:lstStyle/>
+          <a:p>
+            <a:pPr marL="0" indent="0" algn="ctr">
+              <a:buNone/>
+            </a:pPr>
+            <a:r>
+              <a:rPr lang="en-US" sz="1100" b="1" dirty="0">
+                <a:solidFill>
+                  <a:srgbClr val="53565A"/>
+                </a:solidFill>
+                <a:latin typeface="Arial" pitchFamily="34" charset="0"/>
+                <a:ea typeface="Arial" pitchFamily="34" charset="-122"/>
+                <a:cs typeface="Arial" pitchFamily="34" charset="-120"/>
+              </a:rPr>
+              <a:t>↓</a:t>
+            </a:r>
+            <a:endParaRPr lang="en-US" sz="1100" dirty="0"/>
+          </a:p>
+        </p:txBody>
+      </p:sp>
+      <p:sp>
+        <p:nvSpPr>
+          <p:cNvPr id="48" name="Shape 45"/>
+          <p:cNvSpPr/>
+          <p:nvPr/>
+        </p:nvSpPr>
+        <p:spPr>
+          <a:xfrm>
+            <a:off x="4572000" y="4507992"/>
+            <a:ext cx="292608" cy="292608"/>
+          </a:xfrm>
+          <a:prstGeom prst="ellipse">
+            <a:avLst/>
+          </a:prstGeom>
+          <a:solidFill>
+            <a:srgbClr val="53565A"/>
+          </a:solidFill>
+          <a:ln/>
+        </p:spPr>
+        <p:txBody>
+          <a:bodyPr/>
+          <a:lstStyle/>
+          <a:p>
+            <a:endParaRPr lang="en-US"/>
+          </a:p>
+        </p:txBody>
+      </p:sp>
+      <p:sp>
+        <p:nvSpPr>
+          <p:cNvPr id="49" name="Text 46"/>
+          <p:cNvSpPr/>
+          <p:nvPr/>
+        </p:nvSpPr>
+        <p:spPr>
+          <a:xfrm>
+            <a:off x="4572000" y="4507992"/>
+            <a:ext cx="292608" cy="292608"/>
+          </a:xfrm>
+          <a:prstGeom prst="rect">
+            <a:avLst/>
+          </a:prstGeom>
+          <a:noFill/>
+          <a:ln/>
+        </p:spPr>
+        <p:txBody>
+          <a:bodyPr wrap="square" lIns="0" tIns="0" rIns="0" bIns="0" rtlCol="0" anchor="ctr"/>
+          <a:lstStyle/>
+          <a:p>
+            <a:pPr marL="0" indent="0" algn="ctr">
+              <a:buNone/>
+            </a:pPr>
+            <a:r>
+              <a:rPr lang="en-US" sz="1200" b="1" dirty="0">
+                <a:solidFill>
+                  <a:srgbClr val="FFFFFF"/>
+                </a:solidFill>
+                <a:latin typeface="Arial" pitchFamily="34" charset="0"/>
+                <a:ea typeface="Arial" pitchFamily="34" charset="-122"/>
+                <a:cs typeface="Arial" pitchFamily="34" charset="-120"/>
+              </a:rPr>
+              <a:t>5</a:t>
+            </a:r>
+            <a:endParaRPr lang="en-US" sz="1200" dirty="0"/>
+          </a:p>
+        </p:txBody>
+      </p:sp>
+      <p:sp>
+        <p:nvSpPr>
+          <p:cNvPr id="50" name="Text 47"/>
+          <p:cNvSpPr/>
+          <p:nvPr/>
+        </p:nvSpPr>
+        <p:spPr>
+          <a:xfrm>
+            <a:off x="4956048" y="4489704"/>
+            <a:ext cx="4206240" cy="292608"/>
+          </a:xfrm>
+          <a:prstGeom prst="rect">
+            <a:avLst/>
+          </a:prstGeom>
+          <a:noFill/>
+          <a:ln/>
+        </p:spPr>
+        <p:txBody>
+          <a:bodyPr wrap="square" lIns="0" tIns="0" rIns="0" bIns="0" rtlCol="0" anchor="ctr"/>
+          <a:lstStyle/>
+          <a:p>
+            <a:pPr marL="0" indent="0" algn="l">
+              <a:buNone/>
+            </a:pPr>
+            <a:r>
+              <a:rPr lang="en-US" sz="1200" b="1" dirty="0">
+                <a:solidFill>
+                  <a:srgbClr val="005C8A"/>
+                </a:solidFill>
+                <a:latin typeface="Arial" pitchFamily="34" charset="0"/>
+                <a:ea typeface="Arial" pitchFamily="34" charset="-122"/>
+                <a:cs typeface="Arial" pitchFamily="34" charset="-120"/>
+              </a:rPr>
+              <a:t>⑤ GTO/MCP Policy Check</a:t>
+            </a:r>
+            <a:endParaRPr lang="en-US" sz="1200" dirty="0"/>
+          </a:p>
+        </p:txBody>
+      </p:sp>
+      <p:sp>
+        <p:nvSpPr>
+          <p:cNvPr id="51" name="Text 48"/>
+          <p:cNvSpPr/>
+          <p:nvPr/>
+        </p:nvSpPr>
+        <p:spPr>
+          <a:xfrm>
+            <a:off x="9720072" y="4489704"/>
+            <a:ext cx="2011680" cy="292608"/>
+          </a:xfrm>
+          <a:prstGeom prst="rect">
+            <a:avLst/>
+          </a:prstGeom>
+          <a:noFill/>
+          <a:ln/>
+        </p:spPr>
+        <p:txBody>
+          <a:bodyPr wrap="square" lIns="0" tIns="0" rIns="0" bIns="0" rtlCol="0" anchor="ctr"/>
+          <a:lstStyle/>
+          <a:p>
+            <a:pPr marL="0" indent="0" algn="r">
+              <a:buNone/>
+            </a:pPr>
+            <a:r>
+              <a:rPr lang="en-US" sz="950" i="1" dirty="0">
+                <a:solidFill>
+                  <a:srgbClr val="53565A"/>
+                </a:solidFill>
+                <a:latin typeface="Arial" pitchFamily="34" charset="0"/>
+                <a:ea typeface="Arial" pitchFamily="34" charset="-122"/>
+                <a:cs typeface="Arial" pitchFamily="34" charset="-120"/>
+              </a:rPr>
+              <a:t>Policy Gate</a:t>
+            </a:r>
+            <a:endParaRPr lang="en-US" sz="950" dirty="0"/>
+          </a:p>
+        </p:txBody>
+      </p:sp>
+      <p:sp>
+        <p:nvSpPr>
+          <p:cNvPr id="52" name="Shape 49"/>
+          <p:cNvSpPr/>
+          <p:nvPr/>
+        </p:nvSpPr>
+        <p:spPr>
+          <a:xfrm>
+            <a:off x="4572000" y="4818888"/>
+            <a:ext cx="7159752" cy="457200"/>
+          </a:xfrm>
+          <a:prstGeom prst="roundRect">
+            <a:avLst>
+              <a:gd name="adj" fmla="val 10000"/>
+            </a:avLst>
+          </a:prstGeom>
+          <a:solidFill>
+            <a:srgbClr val="FFFFFF"/>
+          </a:solidFill>
+          <a:ln w="9525">
+            <a:solidFill>
+              <a:srgbClr val="EEEFF0"/>
+            </a:solidFill>
+            <a:prstDash val="solid"/>
+          </a:ln>
+        </p:spPr>
+        <p:txBody>
+          <a:bodyPr/>
+          <a:lstStyle/>
+          <a:p>
+            <a:endParaRPr lang="en-US"/>
+          </a:p>
+        </p:txBody>
+      </p:sp>
+      <p:sp>
+        <p:nvSpPr>
+          <p:cNvPr id="53" name="Text 50"/>
+          <p:cNvSpPr/>
+          <p:nvPr/>
+        </p:nvSpPr>
+        <p:spPr>
+          <a:xfrm>
+            <a:off x="4709160" y="4818888"/>
+            <a:ext cx="6885432" cy="457200"/>
+          </a:xfrm>
+          <a:prstGeom prst="rect">
+            <a:avLst/>
+          </a:prstGeom>
+          <a:noFill/>
+          <a:ln/>
+        </p:spPr>
+        <p:txBody>
+          <a:bodyPr wrap="square" lIns="0" tIns="0" rIns="0" bIns="0" rtlCol="0" anchor="ctr"/>
+          <a:lstStyle/>
+          <a:p>
+            <a:pPr marL="0" indent="0" algn="l">
+              <a:buNone/>
+            </a:pPr>
+            <a:r>
+              <a:rPr lang="en-US" sz="900" dirty="0">
+                <a:solidFill>
+                  <a:srgbClr val="3B4652"/>
+                </a:solidFill>
+                <a:latin typeface="Arial" pitchFamily="34" charset="0"/>
+                <a:ea typeface="Arial" pitchFamily="34" charset="-122"/>
+                <a:cs typeface="Arial" pitchFamily="34" charset="-120"/>
+              </a:rPr>
+              <a:t>Confirm whether an agent-callable data API needs the same review as the approved Confluence/GitHub/Jira/Rally MCP servers.</a:t>
+            </a:r>
+            <a:endParaRPr lang="en-US" sz="900" dirty="0"/>
+          </a:p>
+        </p:txBody>
+      </p:sp>
+      <p:sp>
+        <p:nvSpPr>
+          <p:cNvPr id="54" name="Text 51"/>
+          <p:cNvSpPr/>
+          <p:nvPr/>
+        </p:nvSpPr>
+        <p:spPr>
+          <a:xfrm>
+            <a:off x="4572000" y="5285232"/>
+            <a:ext cx="292608" cy="128016"/>
+          </a:xfrm>
+          <a:prstGeom prst="rect">
+            <a:avLst/>
+          </a:prstGeom>
+          <a:noFill/>
+          <a:ln/>
+        </p:spPr>
+        <p:txBody>
+          <a:bodyPr wrap="square" lIns="0" tIns="0" rIns="0" bIns="0" rtlCol="0" anchor="ctr"/>
+          <a:lstStyle/>
+          <a:p>
+            <a:pPr marL="0" indent="0" algn="ctr">
+              <a:buNone/>
+            </a:pPr>
+            <a:r>
+              <a:rPr lang="en-US" sz="1100" b="1" dirty="0">
+                <a:solidFill>
+                  <a:srgbClr val="53565A"/>
+                </a:solidFill>
+                <a:latin typeface="Arial" pitchFamily="34" charset="0"/>
+                <a:ea typeface="Arial" pitchFamily="34" charset="-122"/>
+                <a:cs typeface="Arial" pitchFamily="34" charset="-120"/>
+              </a:rPr>
+              <a:t>↓</a:t>
+            </a:r>
+            <a:endParaRPr lang="en-US" sz="1100" dirty="0"/>
+          </a:p>
+        </p:txBody>
+      </p:sp>
+      <p:sp>
+        <p:nvSpPr>
+          <p:cNvPr id="55" name="Shape 52"/>
+          <p:cNvSpPr/>
+          <p:nvPr/>
+        </p:nvSpPr>
+        <p:spPr>
+          <a:xfrm>
+            <a:off x="4572000" y="5394960"/>
+            <a:ext cx="292608" cy="292608"/>
+          </a:xfrm>
+          <a:prstGeom prst="ellipse">
+            <a:avLst/>
+          </a:prstGeom>
+          <a:solidFill>
+            <a:srgbClr val="007B8C"/>
+          </a:solidFill>
+          <a:ln/>
+        </p:spPr>
+        <p:txBody>
+          <a:bodyPr/>
+          <a:lstStyle/>
+          <a:p>
+            <a:endParaRPr lang="en-US"/>
+          </a:p>
+        </p:txBody>
+      </p:sp>
+      <p:sp>
+        <p:nvSpPr>
+          <p:cNvPr id="56" name="Text 53"/>
+          <p:cNvSpPr/>
+          <p:nvPr/>
+        </p:nvSpPr>
+        <p:spPr>
+          <a:xfrm>
+            <a:off x="4572000" y="5394960"/>
+            <a:ext cx="292608" cy="292608"/>
+          </a:xfrm>
+          <a:prstGeom prst="rect">
+            <a:avLst/>
+          </a:prstGeom>
+          <a:noFill/>
+          <a:ln/>
+        </p:spPr>
+        <p:txBody>
+          <a:bodyPr wrap="square" lIns="0" tIns="0" rIns="0" bIns="0" rtlCol="0" anchor="ctr"/>
+          <a:lstStyle/>
+          <a:p>
+            <a:pPr marL="0" indent="0" algn="ctr">
+              <a:buNone/>
+            </a:pPr>
+            <a:r>
+              <a:rPr lang="en-US" sz="1200" b="1" dirty="0">
+                <a:solidFill>
+                  <a:srgbClr val="FFFFFF"/>
+                </a:solidFill>
+                <a:latin typeface="Arial" pitchFamily="34" charset="0"/>
+                <a:ea typeface="Arial" pitchFamily="34" charset="-122"/>
+                <a:cs typeface="Arial" pitchFamily="34" charset="-120"/>
+              </a:rPr>
+              <a:t>6</a:t>
+            </a:r>
+            <a:endParaRPr lang="en-US" sz="1200" dirty="0"/>
+          </a:p>
+        </p:txBody>
+      </p:sp>
+      <p:sp>
+        <p:nvSpPr>
+          <p:cNvPr id="57" name="Text 54"/>
+          <p:cNvSpPr/>
+          <p:nvPr/>
+        </p:nvSpPr>
+        <p:spPr>
+          <a:xfrm>
+            <a:off x="4956048" y="5376672"/>
+            <a:ext cx="4206240" cy="292608"/>
+          </a:xfrm>
+          <a:prstGeom prst="rect">
+            <a:avLst/>
+          </a:prstGeom>
+          <a:noFill/>
+          <a:ln/>
+        </p:spPr>
+        <p:txBody>
+          <a:bodyPr wrap="square" lIns="0" tIns="0" rIns="0" bIns="0" rtlCol="0" anchor="ctr"/>
+          <a:lstStyle/>
+          <a:p>
+            <a:pPr marL="0" indent="0" algn="l">
+              <a:buNone/>
+            </a:pPr>
+            <a:r>
+              <a:rPr lang="en-US" sz="1200" b="1" dirty="0">
+                <a:solidFill>
+                  <a:srgbClr val="007B8C"/>
+                </a:solidFill>
+                <a:latin typeface="Arial" pitchFamily="34" charset="0"/>
+                <a:ea typeface="Arial" pitchFamily="34" charset="-122"/>
+                <a:cs typeface="Arial" pitchFamily="34" charset="-120"/>
+              </a:rPr>
+              <a:t>⑥ Pilot One Domain</a:t>
+            </a:r>
+            <a:endParaRPr lang="en-US" sz="1200" dirty="0"/>
+          </a:p>
+        </p:txBody>
+      </p:sp>
+      <p:sp>
+        <p:nvSpPr>
+          <p:cNvPr id="58" name="Text 55"/>
+          <p:cNvSpPr/>
+          <p:nvPr/>
+        </p:nvSpPr>
+        <p:spPr>
+          <a:xfrm>
+            <a:off x="9720072" y="5376672"/>
+            <a:ext cx="2011680" cy="292608"/>
+          </a:xfrm>
+          <a:prstGeom prst="rect">
+            <a:avLst/>
+          </a:prstGeom>
+          <a:noFill/>
+          <a:ln/>
+        </p:spPr>
+        <p:txBody>
+          <a:bodyPr wrap="square" lIns="0" tIns="0" rIns="0" bIns="0" rtlCol="0" anchor="ctr"/>
+          <a:lstStyle/>
+          <a:p>
+            <a:pPr marL="0" indent="0" algn="r">
+              <a:buNone/>
+            </a:pPr>
+            <a:r>
+              <a:rPr lang="en-US" sz="950" i="1" dirty="0">
+                <a:solidFill>
+                  <a:srgbClr val="53565A"/>
+                </a:solidFill>
+                <a:latin typeface="Arial" pitchFamily="34" charset="0"/>
+                <a:ea typeface="Arial" pitchFamily="34" charset="-122"/>
+                <a:cs typeface="Arial" pitchFamily="34" charset="-120"/>
+              </a:rPr>
+              <a:t>Pilot</a:t>
+            </a:r>
+            <a:endParaRPr lang="en-US" sz="950" dirty="0"/>
+          </a:p>
+        </p:txBody>
+      </p:sp>
+      <p:sp>
+        <p:nvSpPr>
+          <p:cNvPr id="59" name="Shape 56"/>
+          <p:cNvSpPr/>
+          <p:nvPr/>
+        </p:nvSpPr>
+        <p:spPr>
+          <a:xfrm>
+            <a:off x="4572000" y="5705856"/>
+            <a:ext cx="7159752" cy="457200"/>
+          </a:xfrm>
+          <a:prstGeom prst="roundRect">
+            <a:avLst>
+              <a:gd name="adj" fmla="val 10000"/>
+            </a:avLst>
+          </a:prstGeom>
+          <a:solidFill>
+            <a:srgbClr val="FFFFFF"/>
+          </a:solidFill>
+          <a:ln w="9525">
+            <a:solidFill>
+              <a:srgbClr val="EEEFF0"/>
+            </a:solidFill>
+            <a:prstDash val="solid"/>
+          </a:ln>
+        </p:spPr>
+        <p:txBody>
+          <a:bodyPr/>
+          <a:lstStyle/>
+          <a:p>
+            <a:endParaRPr lang="en-US"/>
+          </a:p>
+        </p:txBody>
+      </p:sp>
+      <p:sp>
+        <p:nvSpPr>
+          <p:cNvPr id="60" name="Text 57"/>
+          <p:cNvSpPr/>
+          <p:nvPr/>
+        </p:nvSpPr>
+        <p:spPr>
+          <a:xfrm>
+            <a:off x="4709160" y="5705856"/>
+            <a:ext cx="6885432" cy="457200"/>
+          </a:xfrm>
+          <a:prstGeom prst="rect">
+            <a:avLst/>
+          </a:prstGeom>
+          <a:noFill/>
+          <a:ln/>
+        </p:spPr>
+        <p:txBody>
+          <a:bodyPr wrap="square" lIns="0" tIns="0" rIns="0" bIns="0" rtlCol="0" anchor="ctr"/>
+          <a:lstStyle/>
+          <a:p>
+            <a:pPr marL="0" indent="0" algn="l">
+              <a:buNone/>
+            </a:pPr>
+            <a:r>
+              <a:rPr lang="en-US" sz="900" dirty="0">
+                <a:solidFill>
+                  <a:srgbClr val="3B4652"/>
+                </a:solidFill>
+                <a:latin typeface="Arial" pitchFamily="34" charset="0"/>
+                <a:ea typeface="Arial" pitchFamily="34" charset="-122"/>
+                <a:cs typeface="Arial" pitchFamily="34" charset="-120"/>
+              </a:rPr>
+              <a:t>Ship #1+#2 for one domain end-to-end — prove the pattern before scaling to the rest of the catalog.</a:t>
+            </a:r>
+            <a:endParaRPr lang="en-US" sz="900" dirty="0"/>
+          </a:p>
+        </p:txBody>
+      </p:sp>
+    </p:spTree>
+  </p:cSld>
+  <p:clrMapOvr>
+    <a:masterClrMapping/>
+  </p:clrMapOvr>
+</p:sld>
+</file>
+
+<file path=ppt/slides/slide8.xml><?xml version="1.0" encoding="utf-8"?>
+<p:sld xmlns:a="http://schemas.openxmlformats.org/drawingml/2006/main" xmlns:r="http://schemas.openxmlformats.org/officeDocument/2006/relationships" xmlns:p="http://schemas.openxmlformats.org/presentationml/2006/main">
+  <p:cSld name="Slide 6">
+    <p:spTree>
+      <p:nvGrpSpPr>
+        <p:cNvPr id="1" name=""/>
+        <p:cNvGrpSpPr/>
+        <p:nvPr/>
+      </p:nvGrpSpPr>
+      <p:grpSpPr>
+        <a:xfrm>
+          <a:off x="0" y="0"/>
+          <a:ext cx="0" cy="0"/>
+          <a:chOff x="0" y="0"/>
+          <a:chExt cx="0" cy="0"/>
+        </a:xfrm>
+      </p:grpSpPr>
+      <p:sp>
+        <p:nvSpPr>
+          <p:cNvPr id="2" name="Shape 0"/>
+          <p:cNvSpPr/>
+          <p:nvPr/>
+        </p:nvSpPr>
+        <p:spPr>
+          <a:xfrm>
+            <a:off x="0" y="0"/>
+            <a:ext cx="4114800" cy="6858000"/>
+          </a:xfrm>
+          <a:prstGeom prst="rect">
+            <a:avLst/>
+          </a:prstGeom>
+          <a:solidFill>
+            <a:srgbClr val="3B4652"/>
+          </a:solidFill>
+          <a:ln/>
+        </p:spPr>
+        <p:txBody>
+          <a:bodyPr/>
+          <a:lstStyle/>
+          <a:p>
+            <a:endParaRPr lang="en-US"/>
+          </a:p>
+        </p:txBody>
+      </p:sp>
+      <p:sp>
+        <p:nvSpPr>
+          <p:cNvPr id="3" name="Shape 1"/>
+          <p:cNvSpPr/>
+          <p:nvPr/>
+        </p:nvSpPr>
+        <p:spPr>
+          <a:xfrm>
+            <a:off x="457200" y="457200"/>
+            <a:ext cx="566928" cy="566928"/>
+          </a:xfrm>
+          <a:prstGeom prst="ellipse">
+            <a:avLst/>
+          </a:prstGeom>
+          <a:solidFill>
+            <a:srgbClr val="0098C7"/>
+          </a:solidFill>
+          <a:ln/>
+        </p:spPr>
+        <p:txBody>
+          <a:bodyPr/>
+          <a:lstStyle/>
+          <a:p>
+            <a:endParaRPr lang="en-US"/>
+          </a:p>
+        </p:txBody>
+      </p:sp>
+      <p:pic>
+        <p:nvPicPr>
+          <p:cNvPr id="4" name="Image 0" descr="preencoded.png"/>
+          <p:cNvPicPr>
+            <a:picLocks noChangeAspect="1"/>
+          </p:cNvPicPr>
+          <p:nvPr/>
+        </p:nvPicPr>
+        <p:blipFill>
+          <a:blip r:embed="rId3"/>
+          <a:stretch>
+            <a:fillRect/>
+          </a:stretch>
+        </p:blipFill>
+        <p:spPr>
+          <a:xfrm>
+            <a:off x="576072" y="576072"/>
+            <a:ext cx="329184" cy="329184"/>
+          </a:xfrm>
+          <a:prstGeom prst="rect">
+            <a:avLst/>
+          </a:prstGeom>
+        </p:spPr>
+      </p:pic>
+      <p:sp>
+        <p:nvSpPr>
+          <p:cNvPr id="5" name="Text 2"/>
+          <p:cNvSpPr/>
+          <p:nvPr/>
+        </p:nvSpPr>
+        <p:spPr>
+          <a:xfrm>
+            <a:off x="1170432" y="384048"/>
+            <a:ext cx="2788920" cy="685800"/>
+          </a:xfrm>
+          <a:prstGeom prst="rect">
+            <a:avLst/>
+          </a:prstGeom>
+          <a:noFill/>
+          <a:ln/>
+        </p:spPr>
+        <p:txBody>
+          <a:bodyPr wrap="square" lIns="0" tIns="0" rIns="0" bIns="0" rtlCol="0" anchor="t"/>
+          <a:lstStyle/>
+          <a:p>
+            <a:pPr marL="0" indent="0" algn="l">
+              <a:lnSpc>
+                <a:spcPct val="102000"/>
+              </a:lnSpc>
+              <a:buNone/>
+            </a:pPr>
+            <a:r>
+              <a:rPr lang="en-US" sz="2200" b="1" dirty="0">
+                <a:solidFill>
+                  <a:srgbClr val="FFFFFF"/>
+                </a:solidFill>
+                <a:latin typeface="Arial" pitchFamily="34" charset="0"/>
+                <a:ea typeface="Arial" pitchFamily="34" charset="-122"/>
+                <a:cs typeface="Arial" pitchFamily="34" charset="-120"/>
+              </a:rPr>
+              <a:t>WSD Data Access Co-Pilot</a:t>
+            </a:r>
+            <a:endParaRPr lang="en-US" sz="2200" dirty="0"/>
+          </a:p>
+        </p:txBody>
+      </p:sp>
+      <p:sp>
+        <p:nvSpPr>
+          <p:cNvPr id="6" name="Text 3"/>
+          <p:cNvSpPr/>
+          <p:nvPr/>
+        </p:nvSpPr>
+        <p:spPr>
+          <a:xfrm>
+            <a:off x="429768" y="1170432"/>
+            <a:ext cx="3383280" cy="502920"/>
+          </a:xfrm>
+          <a:prstGeom prst="rect">
+            <a:avLst/>
+          </a:prstGeom>
+          <a:noFill/>
+          <a:ln/>
+        </p:spPr>
+        <p:txBody>
+          <a:bodyPr wrap="square" lIns="0" tIns="0" rIns="0" bIns="0" rtlCol="0" anchor="t"/>
+          <a:lstStyle/>
+          <a:p>
+            <a:pPr marL="0" indent="0" algn="l">
+              <a:buNone/>
+            </a:pPr>
+            <a:r>
+              <a:rPr lang="en-US" sz="1250" dirty="0">
+                <a:solidFill>
+                  <a:srgbClr val="EEEFF0"/>
+                </a:solidFill>
+                <a:latin typeface="Arial" pitchFamily="34" charset="0"/>
+                <a:ea typeface="Arial" pitchFamily="34" charset="-122"/>
+                <a:cs typeface="Arial" pitchFamily="34" charset="-120"/>
+              </a:rPr>
+              <a:t>Appendix — held for later: composite-ID resolution as its own service</a:t>
+            </a:r>
+            <a:endParaRPr lang="en-US" sz="1250" dirty="0"/>
+          </a:p>
+        </p:txBody>
+      </p:sp>
+      <p:sp>
+        <p:nvSpPr>
+          <p:cNvPr id="7" name="Text 4"/>
+          <p:cNvSpPr/>
+          <p:nvPr/>
+        </p:nvSpPr>
+        <p:spPr>
+          <a:xfrm>
+            <a:off x="457200" y="1783080"/>
+            <a:ext cx="3291840" cy="237744"/>
+          </a:xfrm>
+          <a:prstGeom prst="rect">
+            <a:avLst/>
+          </a:prstGeom>
+          <a:noFill/>
+          <a:ln/>
+        </p:spPr>
+        <p:txBody>
+          <a:bodyPr wrap="square" lIns="0" tIns="0" rIns="0" bIns="0" rtlCol="0" anchor="ctr"/>
+          <a:lstStyle/>
+          <a:p>
+            <a:pPr marL="0" indent="0">
+              <a:buNone/>
+            </a:pPr>
+            <a:r>
+              <a:rPr lang="en-US" sz="1100" b="1" dirty="0">
+                <a:solidFill>
+                  <a:srgbClr val="0098C7"/>
+                </a:solidFill>
+                <a:latin typeface="Arial" pitchFamily="34" charset="0"/>
+                <a:ea typeface="Arial" pitchFamily="34" charset="-122"/>
+                <a:cs typeface="Arial" pitchFamily="34" charset="-120"/>
+              </a:rPr>
+              <a:t>THE IDEA</a:t>
+            </a:r>
+            <a:endParaRPr lang="en-US" sz="1100" dirty="0"/>
+          </a:p>
+        </p:txBody>
+      </p:sp>
+      <p:sp>
+        <p:nvSpPr>
+          <p:cNvPr id="8" name="Text 5"/>
+          <p:cNvSpPr/>
+          <p:nvPr/>
+        </p:nvSpPr>
+        <p:spPr>
+          <a:xfrm>
+            <a:off x="457200" y="2039112"/>
+            <a:ext cx="3337560" cy="630936"/>
+          </a:xfrm>
+          <a:prstGeom prst="rect">
+            <a:avLst/>
+          </a:prstGeom>
+          <a:noFill/>
+          <a:ln/>
+        </p:spPr>
+        <p:txBody>
+          <a:bodyPr wrap="square" lIns="0" tIns="0" rIns="0" bIns="0" rtlCol="0" anchor="t"/>
+          <a:lstStyle/>
+          <a:p>
+            <a:pPr marL="0" indent="0">
+              <a:buNone/>
+            </a:pPr>
+            <a:r>
+              <a:rPr lang="en-US" sz="1200" dirty="0">
+                <a:solidFill>
+                  <a:srgbClr val="EEEFF0"/>
+                </a:solidFill>
+                <a:latin typeface="Arial" pitchFamily="34" charset="0"/>
+                <a:ea typeface="Arial" pitchFamily="34" charset="-122"/>
+                <a:cs typeface="Arial" pitchFamily="34" charset="-120"/>
+              </a:rPr>
+              <a:t>Extract composite-ID resolution (wafer/lot filename decoding) out of Co-Pilot into its own standalone, independently-callable service.</a:t>
+            </a:r>
+            <a:endParaRPr lang="en-US" sz="1200" dirty="0"/>
+          </a:p>
+        </p:txBody>
+      </p:sp>
+      <p:sp>
+        <p:nvSpPr>
+          <p:cNvPr id="9" name="Shape 6"/>
+          <p:cNvSpPr/>
+          <p:nvPr/>
+        </p:nvSpPr>
+        <p:spPr>
+          <a:xfrm>
+            <a:off x="457200" y="2825496"/>
+            <a:ext cx="54864" cy="1271016"/>
+          </a:xfrm>
+          <a:prstGeom prst="rect">
+            <a:avLst/>
+          </a:prstGeom>
+          <a:solidFill>
+            <a:srgbClr val="007B8C"/>
+          </a:solidFill>
+          <a:ln/>
+        </p:spPr>
+        <p:txBody>
+          <a:bodyPr/>
+          <a:lstStyle/>
+          <a:p>
+            <a:endParaRPr lang="en-US"/>
+          </a:p>
+        </p:txBody>
+      </p:sp>
+      <p:sp>
+        <p:nvSpPr>
+          <p:cNvPr id="10" name="Text 7"/>
+          <p:cNvSpPr/>
+          <p:nvPr/>
+        </p:nvSpPr>
+        <p:spPr>
+          <a:xfrm>
+            <a:off x="640080" y="2825496"/>
+            <a:ext cx="3108960" cy="237744"/>
+          </a:xfrm>
+          <a:prstGeom prst="rect">
+            <a:avLst/>
+          </a:prstGeom>
+          <a:noFill/>
+          <a:ln/>
+        </p:spPr>
+        <p:txBody>
+          <a:bodyPr wrap="square" lIns="0" tIns="0" rIns="0" bIns="0" rtlCol="0" anchor="ctr"/>
+          <a:lstStyle/>
+          <a:p>
+            <a:pPr marL="0" indent="0">
+              <a:buNone/>
+            </a:pPr>
+            <a:r>
+              <a:rPr lang="en-US" sz="1100" b="1" dirty="0">
+                <a:solidFill>
+                  <a:srgbClr val="007B8C"/>
+                </a:solidFill>
+                <a:latin typeface="Arial" pitchFamily="34" charset="0"/>
+                <a:ea typeface="Arial" pitchFamily="34" charset="-122"/>
+                <a:cs typeface="Arial" pitchFamily="34" charset="-120"/>
+              </a:rPr>
+              <a:t>WHY IT'S HELD</a:t>
+            </a:r>
+            <a:endParaRPr lang="en-US" sz="1100" dirty="0"/>
+          </a:p>
+        </p:txBody>
+      </p:sp>
+      <p:sp>
+        <p:nvSpPr>
+          <p:cNvPr id="11" name="Text 8"/>
+          <p:cNvSpPr/>
+          <p:nvPr/>
+        </p:nvSpPr>
+        <p:spPr>
+          <a:xfrm>
+            <a:off x="640080" y="3081528"/>
+            <a:ext cx="3063240" cy="1014984"/>
+          </a:xfrm>
+          <a:prstGeom prst="rect">
+            <a:avLst/>
+          </a:prstGeom>
+          <a:noFill/>
+          <a:ln/>
+        </p:spPr>
+        <p:txBody>
+          <a:bodyPr wrap="square" lIns="0" tIns="0" rIns="0" bIns="0" rtlCol="0" anchor="t"/>
+          <a:lstStyle/>
+          <a:p>
+            <a:pPr marL="0" indent="0">
+              <a:buNone/>
+            </a:pPr>
+            <a:r>
+              <a:rPr lang="en-US" sz="1150" dirty="0">
+                <a:solidFill>
+                  <a:srgbClr val="EEEFF0"/>
+                </a:solidFill>
+                <a:latin typeface="Arial" pitchFamily="34" charset="0"/>
+                <a:ea typeface="Arial" pitchFamily="34" charset="-122"/>
+                <a:cs typeface="Arial" pitchFamily="34" charset="-120"/>
+              </a:rPr>
+              <a:t>Its difficulty is gated by v1's deterministic-assembly module (steps ④⑤) proving out in production first — not by any lack of value in the idea.</a:t>
+            </a:r>
+            <a:endParaRPr lang="en-US" sz="1150" dirty="0"/>
+          </a:p>
+        </p:txBody>
+      </p:sp>
+      <p:sp>
+        <p:nvSpPr>
+          <p:cNvPr id="12" name="Shape 9"/>
+          <p:cNvSpPr/>
+          <p:nvPr/>
+        </p:nvSpPr>
+        <p:spPr>
+          <a:xfrm>
+            <a:off x="457200" y="4233672"/>
+            <a:ext cx="54864" cy="1042416"/>
+          </a:xfrm>
+          <a:prstGeom prst="rect">
+            <a:avLst/>
+          </a:prstGeom>
+          <a:solidFill>
+            <a:srgbClr val="0098C7"/>
+          </a:solidFill>
+          <a:ln/>
+        </p:spPr>
+        <p:txBody>
+          <a:bodyPr/>
+          <a:lstStyle/>
+          <a:p>
+            <a:endParaRPr lang="en-US"/>
+          </a:p>
+        </p:txBody>
+      </p:sp>
+      <p:sp>
+        <p:nvSpPr>
+          <p:cNvPr id="13" name="Text 10"/>
+          <p:cNvSpPr/>
+          <p:nvPr/>
+        </p:nvSpPr>
+        <p:spPr>
+          <a:xfrm>
+            <a:off x="640080" y="4233672"/>
+            <a:ext cx="3108960" cy="237744"/>
+          </a:xfrm>
+          <a:prstGeom prst="rect">
+            <a:avLst/>
+          </a:prstGeom>
+          <a:noFill/>
+          <a:ln/>
+        </p:spPr>
+        <p:txBody>
+          <a:bodyPr wrap="square" lIns="0" tIns="0" rIns="0" bIns="0" rtlCol="0" anchor="ctr"/>
+          <a:lstStyle/>
+          <a:p>
+            <a:pPr marL="0" indent="0">
+              <a:buNone/>
+            </a:pPr>
+            <a:r>
+              <a:rPr lang="en-US" sz="1100" b="1" dirty="0">
+                <a:solidFill>
+                  <a:srgbClr val="0098C7"/>
+                </a:solidFill>
+                <a:latin typeface="Arial" pitchFamily="34" charset="0"/>
+                <a:ea typeface="Arial" pitchFamily="34" charset="-122"/>
+                <a:cs typeface="Arial" pitchFamily="34" charset="-120"/>
+              </a:rPr>
+              <a:t>WHY IT'S WORTH REVISITING</a:t>
+            </a:r>
+            <a:endParaRPr lang="en-US" sz="1100" dirty="0"/>
+          </a:p>
+        </p:txBody>
+      </p:sp>
+      <p:sp>
+        <p:nvSpPr>
+          <p:cNvPr id="14" name="Text 11"/>
+          <p:cNvSpPr/>
+          <p:nvPr/>
+        </p:nvSpPr>
+        <p:spPr>
+          <a:xfrm>
+            <a:off x="640080" y="4489704"/>
+            <a:ext cx="3063240" cy="786384"/>
+          </a:xfrm>
+          <a:prstGeom prst="rect">
+            <a:avLst/>
+          </a:prstGeom>
+          <a:noFill/>
+          <a:ln/>
+        </p:spPr>
+        <p:txBody>
+          <a:bodyPr wrap="square" lIns="0" tIns="0" rIns="0" bIns="0" rtlCol="0" anchor="t"/>
+          <a:lstStyle/>
+          <a:p>
+            <a:pPr marL="0" indent="0">
+              <a:buNone/>
+            </a:pPr>
+            <a:r>
+              <a:rPr lang="en-US" sz="1150" dirty="0">
+                <a:solidFill>
+                  <a:srgbClr val="EEEFF0"/>
+                </a:solidFill>
+                <a:latin typeface="Arial" pitchFamily="34" charset="0"/>
+                <a:ea typeface="Arial" pitchFamily="34" charset="-122"/>
+                <a:cs typeface="Arial" pitchFamily="34" charset="-120"/>
+              </a:rPr>
+              <a:t>Both sampled domains (be-module, fbar-wafer) lean on composite identifiers — a standalone resolver pays off for every future agent-facing API, not just this one.</a:t>
+            </a:r>
+            <a:endParaRPr lang="en-US" sz="1150" dirty="0"/>
+          </a:p>
+        </p:txBody>
+      </p:sp>
+      <p:sp>
+        <p:nvSpPr>
+          <p:cNvPr id="15" name="Shape 12"/>
+          <p:cNvSpPr/>
+          <p:nvPr/>
+        </p:nvSpPr>
+        <p:spPr>
+          <a:xfrm>
+            <a:off x="457200" y="5623560"/>
+            <a:ext cx="3337560" cy="914400"/>
+          </a:xfrm>
+          <a:prstGeom prst="roundRect">
+            <a:avLst>
+              <a:gd name="adj" fmla="val 8000"/>
+            </a:avLst>
+          </a:prstGeom>
+          <a:solidFill>
+            <a:srgbClr val="3B4652"/>
+          </a:solidFill>
+          <a:ln w="12700">
+            <a:solidFill>
+              <a:srgbClr val="0098C7"/>
+            </a:solidFill>
+            <a:prstDash val="solid"/>
+          </a:ln>
+        </p:spPr>
+        <p:txBody>
+          <a:bodyPr/>
+          <a:lstStyle/>
+          <a:p>
+            <a:endParaRPr lang="en-US"/>
+          </a:p>
+        </p:txBody>
+      </p:sp>
+      <p:sp>
+        <p:nvSpPr>
+          <p:cNvPr id="16" name="Text 13"/>
+          <p:cNvSpPr/>
+          <p:nvPr/>
+        </p:nvSpPr>
+        <p:spPr>
+          <a:xfrm>
+            <a:off x="658368" y="5742432"/>
+            <a:ext cx="2971800" cy="685800"/>
+          </a:xfrm>
+          <a:prstGeom prst="rect">
+            <a:avLst/>
+          </a:prstGeom>
+          <a:noFill/>
+          <a:ln/>
+        </p:spPr>
+        <p:txBody>
+          <a:bodyPr wrap="square" lIns="0" tIns="0" rIns="0" bIns="0" rtlCol="0" anchor="t"/>
+          <a:lstStyle/>
+          <a:p>
+            <a:pPr marL="0" indent="0">
+              <a:buNone/>
+            </a:pPr>
+            <a:r>
+              <a:rPr lang="en-US" sz="1050" b="1" dirty="0">
+                <a:solidFill>
+                  <a:srgbClr val="0098C7"/>
+                </a:solidFill>
+                <a:latin typeface="Arial" pitchFamily="34" charset="0"/>
+                <a:ea typeface="Arial" pitchFamily="34" charset="-122"/>
+                <a:cs typeface="Arial" pitchFamily="34" charset="-120"/>
+              </a:rPr>
+              <a:t>STATUS</a:t>
+            </a:r>
+            <a:endParaRPr lang="en-US" sz="1050" dirty="0"/>
+          </a:p>
+          <a:p>
+            <a:pPr marL="0" indent="0">
+              <a:buNone/>
+            </a:pPr>
+            <a:r>
+              <a:rPr lang="en-US" sz="1250" b="1" dirty="0">
+                <a:solidFill>
+                  <a:srgbClr val="FFFFFF"/>
+                </a:solidFill>
+                <a:latin typeface="Arial" pitchFamily="34" charset="0"/>
+                <a:ea typeface="Arial" pitchFamily="34" charset="-122"/>
+                <a:cs typeface="Arial" pitchFamily="34" charset="-120"/>
+              </a:rPr>
+              <a:t>Held — not scoped, revisit after v1's deterministic core runs in production</a:t>
+            </a:r>
+            <a:endParaRPr lang="en-US" sz="1050" dirty="0"/>
+          </a:p>
+        </p:txBody>
+      </p:sp>
+      <p:sp>
+        <p:nvSpPr>
+          <p:cNvPr id="17" name="Text 14"/>
+          <p:cNvSpPr/>
+          <p:nvPr/>
+        </p:nvSpPr>
+        <p:spPr>
+          <a:xfrm>
+            <a:off x="4572000" y="256032"/>
+            <a:ext cx="7159752" cy="365760"/>
+          </a:xfrm>
+          <a:prstGeom prst="rect">
+            <a:avLst/>
+          </a:prstGeom>
+          <a:noFill/>
+          <a:ln/>
+        </p:spPr>
+        <p:txBody>
+          <a:bodyPr wrap="square" lIns="0" tIns="0" rIns="0" bIns="0" rtlCol="0" anchor="ctr"/>
+          <a:lstStyle/>
+          <a:p>
+            <a:pPr marL="0" indent="0">
+              <a:buNone/>
+            </a:pPr>
+            <a:r>
+              <a:rPr lang="en-US" sz="1900" b="1" dirty="0">
+                <a:solidFill>
+                  <a:srgbClr val="005C8A"/>
+                </a:solidFill>
+                <a:latin typeface="Arial" pitchFamily="34" charset="0"/>
+                <a:ea typeface="Arial" pitchFamily="34" charset="-122"/>
+                <a:cs typeface="Arial" pitchFamily="34" charset="-120"/>
+              </a:rPr>
+              <a:t>COMPOSITE-ID RESOLUTION SERVICE (#3) — HELD</a:t>
+            </a:r>
+            <a:endParaRPr lang="en-US" sz="1900" dirty="0"/>
+          </a:p>
+        </p:txBody>
+      </p:sp>
+      <p:sp>
+        <p:nvSpPr>
+          <p:cNvPr id="18" name="Text 15"/>
+          <p:cNvSpPr/>
+          <p:nvPr/>
+        </p:nvSpPr>
+        <p:spPr>
+          <a:xfrm>
+            <a:off x="4572000" y="694944"/>
+            <a:ext cx="7159752" cy="292608"/>
+          </a:xfrm>
+          <a:prstGeom prst="rect">
+            <a:avLst/>
+          </a:prstGeom>
+          <a:noFill/>
+          <a:ln/>
+        </p:spPr>
+        <p:txBody>
+          <a:bodyPr wrap="square" lIns="0" tIns="0" rIns="0" bIns="0" rtlCol="0" anchor="ctr"/>
+          <a:lstStyle/>
+          <a:p>
+            <a:pPr marL="0" indent="0">
+              <a:buNone/>
+            </a:pPr>
+            <a:r>
+              <a:rPr lang="en-US" sz="1250" b="1" dirty="0">
+                <a:solidFill>
+                  <a:srgbClr val="53565A"/>
+                </a:solidFill>
+                <a:latin typeface="Arial" pitchFamily="34" charset="0"/>
+                <a:ea typeface="Arial" pitchFamily="34" charset="-122"/>
+                <a:cs typeface="Arial" pitchFamily="34" charset="-120"/>
+              </a:rPr>
+              <a:t>Real value, wrong time.</a:t>
+            </a:r>
+            <a:endParaRPr lang="en-US" sz="1250" dirty="0"/>
+          </a:p>
+        </p:txBody>
+      </p:sp>
+      <p:sp>
+        <p:nvSpPr>
+          <p:cNvPr id="19" name="Text 16"/>
+          <p:cNvSpPr/>
+          <p:nvPr/>
+        </p:nvSpPr>
+        <p:spPr>
+          <a:xfrm>
+            <a:off x="4572000" y="987552"/>
+            <a:ext cx="7159752" cy="292608"/>
+          </a:xfrm>
+          <a:prstGeom prst="rect">
+            <a:avLst/>
+          </a:prstGeom>
+          <a:noFill/>
+          <a:ln/>
+        </p:spPr>
+        <p:txBody>
+          <a:bodyPr wrap="square" lIns="0" tIns="0" rIns="0" bIns="0" rtlCol="0" anchor="ctr"/>
+          <a:lstStyle/>
+          <a:p>
+            <a:pPr marL="0" indent="0">
+              <a:buNone/>
+            </a:pPr>
+            <a:r>
+              <a:rPr lang="en-US" sz="1100" dirty="0">
+                <a:solidFill>
+                  <a:srgbClr val="53565A"/>
+                </a:solidFill>
+                <a:latin typeface="Arial" pitchFamily="34" charset="0"/>
+                <a:ea typeface="Arial" pitchFamily="34" charset="-122"/>
+                <a:cs typeface="Arial" pitchFamily="34" charset="-120"/>
+              </a:rPr>
+              <a:t>This depends on something that hasn't shipped yet — not part of the #1+#2 to-do plan.</a:t>
+            </a:r>
+            <a:endParaRPr lang="en-US" sz="1100" dirty="0"/>
+          </a:p>
+        </p:txBody>
+      </p:sp>
+      <p:sp>
+        <p:nvSpPr>
+          <p:cNvPr id="20" name="Shape 17"/>
+          <p:cNvSpPr/>
+          <p:nvPr/>
+        </p:nvSpPr>
+        <p:spPr>
+          <a:xfrm>
+            <a:off x="4572000" y="1591056"/>
+            <a:ext cx="3502152" cy="1874520"/>
+          </a:xfrm>
+          <a:prstGeom prst="roundRect">
+            <a:avLst>
+              <a:gd name="adj" fmla="val 3902"/>
+            </a:avLst>
+          </a:prstGeom>
+          <a:solidFill>
+            <a:srgbClr val="FFFFFF"/>
+          </a:solidFill>
+          <a:ln w="9525">
+            <a:solidFill>
+              <a:srgbClr val="EEEFF0"/>
+            </a:solidFill>
+            <a:prstDash val="solid"/>
+          </a:ln>
+        </p:spPr>
+        <p:txBody>
+          <a:bodyPr/>
+          <a:lstStyle/>
+          <a:p>
+            <a:endParaRPr lang="en-US"/>
+          </a:p>
+        </p:txBody>
+      </p:sp>
+      <p:sp>
+        <p:nvSpPr>
+          <p:cNvPr id="21" name="Shape 18"/>
+          <p:cNvSpPr/>
+          <p:nvPr/>
+        </p:nvSpPr>
+        <p:spPr>
+          <a:xfrm>
+            <a:off x="6067044" y="1755648"/>
+            <a:ext cx="512064" cy="512064"/>
+          </a:xfrm>
+          <a:prstGeom prst="ellipse">
+            <a:avLst/>
+          </a:prstGeom>
+          <a:solidFill>
+            <a:srgbClr val="0098C7"/>
+          </a:solidFill>
+          <a:ln/>
+        </p:spPr>
+        <p:txBody>
+          <a:bodyPr/>
+          <a:lstStyle/>
+          <a:p>
+            <a:endParaRPr lang="en-US"/>
+          </a:p>
+        </p:txBody>
+      </p:sp>
+      <p:pic>
+        <p:nvPicPr>
+          <p:cNvPr id="22" name="Image 1" descr="preencoded.png"/>
+          <p:cNvPicPr>
+            <a:picLocks noChangeAspect="1"/>
+          </p:cNvPicPr>
+          <p:nvPr/>
+        </p:nvPicPr>
+        <p:blipFill>
+          <a:blip r:embed="rId4"/>
+          <a:stretch>
+            <a:fillRect/>
+          </a:stretch>
+        </p:blipFill>
+        <p:spPr>
+          <a:xfrm>
+            <a:off x="6176772" y="1865376"/>
+            <a:ext cx="292608" cy="292608"/>
+          </a:xfrm>
+          <a:prstGeom prst="rect">
+            <a:avLst/>
+          </a:prstGeom>
+        </p:spPr>
+      </p:pic>
+      <p:sp>
+        <p:nvSpPr>
+          <p:cNvPr id="23" name="Text 19"/>
+          <p:cNvSpPr/>
+          <p:nvPr/>
+        </p:nvSpPr>
+        <p:spPr>
+          <a:xfrm>
+            <a:off x="4645152" y="2377440"/>
+            <a:ext cx="3355848" cy="420624"/>
+          </a:xfrm>
+          <a:prstGeom prst="rect">
+            <a:avLst/>
+          </a:prstGeom>
+          <a:noFill/>
+          <a:ln/>
+        </p:spPr>
+        <p:txBody>
+          <a:bodyPr wrap="square" lIns="0" tIns="0" rIns="0" bIns="0" rtlCol="0" anchor="t"/>
+          <a:lstStyle/>
+          <a:p>
+            <a:pPr marL="0" indent="0" algn="l">
+              <a:buNone/>
+            </a:pPr>
+            <a:r>
+              <a:rPr lang="en-US" sz="1250" b="1" dirty="0">
+                <a:solidFill>
+                  <a:srgbClr val="005C8A"/>
+                </a:solidFill>
+                <a:latin typeface="Arial" pitchFamily="34" charset="0"/>
+                <a:ea typeface="Arial" pitchFamily="34" charset="-122"/>
+                <a:cs typeface="Arial" pitchFamily="34" charset="-120"/>
+              </a:rPr>
+              <a:t>What It Would Be</a:t>
+            </a:r>
+            <a:endParaRPr lang="en-US" sz="1250" dirty="0"/>
+          </a:p>
+        </p:txBody>
+      </p:sp>
+      <p:sp>
+        <p:nvSpPr>
+          <p:cNvPr id="24" name="Text 20"/>
+          <p:cNvSpPr/>
+          <p:nvPr/>
+        </p:nvSpPr>
+        <p:spPr>
+          <a:xfrm>
+            <a:off x="4645152" y="2798064"/>
+            <a:ext cx="3355848" cy="594360"/>
+          </a:xfrm>
+          <a:prstGeom prst="rect">
+            <a:avLst/>
+          </a:prstGeom>
+          <a:noFill/>
+          <a:ln/>
+        </p:spPr>
+        <p:txBody>
+          <a:bodyPr wrap="square" lIns="0" tIns="0" rIns="0" bIns="0" rtlCol="0" anchor="t"/>
+          <a:lstStyle/>
+          <a:p>
+            <a:pPr marL="0" indent="0" algn="l">
+              <a:buNone/>
+            </a:pPr>
+            <a:r>
+              <a:rPr lang="en-US" sz="950" dirty="0">
+                <a:solidFill>
+                  <a:srgbClr val="53565A"/>
+                </a:solidFill>
+                <a:latin typeface="Arial" pitchFamily="34" charset="0"/>
+                <a:ea typeface="Arial" pitchFamily="34" charset="-122"/>
+                <a:cs typeface="Arial" pitchFamily="34" charset="-120"/>
+              </a:rPr>
+              <a:t>resolve_composite_id(...) → filename, and the inverse parse_composite_id(filename) → {fields} — callable independently of the Co-Pilot pipeline.</a:t>
+            </a:r>
+            <a:endParaRPr lang="en-US" sz="950" dirty="0"/>
+          </a:p>
+        </p:txBody>
+      </p:sp>
+      <p:sp>
+        <p:nvSpPr>
+          <p:cNvPr id="25" name="Text 21"/>
+          <p:cNvSpPr/>
+          <p:nvPr/>
+        </p:nvSpPr>
+        <p:spPr>
+          <a:xfrm>
+            <a:off x="8074152" y="2327148"/>
+            <a:ext cx="155448" cy="402336"/>
+          </a:xfrm>
+          <a:prstGeom prst="rect">
+            <a:avLst/>
+          </a:prstGeom>
+          <a:noFill/>
+          <a:ln/>
+        </p:spPr>
+        <p:txBody>
+          <a:bodyPr wrap="square" lIns="0" tIns="0" rIns="0" bIns="0" rtlCol="0" anchor="ctr"/>
+          <a:lstStyle/>
+          <a:p>
+            <a:pPr marL="0" indent="0" algn="ctr">
+              <a:buNone/>
+            </a:pPr>
+            <a:r>
+              <a:rPr lang="en-US" sz="2000" b="1" dirty="0">
+                <a:solidFill>
+                  <a:srgbClr val="53565A"/>
+                </a:solidFill>
+                <a:latin typeface="Arial" pitchFamily="34" charset="0"/>
+                <a:ea typeface="Arial" pitchFamily="34" charset="-122"/>
+                <a:cs typeface="Arial" pitchFamily="34" charset="-120"/>
+              </a:rPr>
+              <a:t>›</a:t>
+            </a:r>
+            <a:endParaRPr lang="en-US" sz="2000" dirty="0"/>
+          </a:p>
+        </p:txBody>
+      </p:sp>
+      <p:sp>
+        <p:nvSpPr>
+          <p:cNvPr id="26" name="Shape 22"/>
+          <p:cNvSpPr/>
+          <p:nvPr/>
+        </p:nvSpPr>
+        <p:spPr>
+          <a:xfrm>
+            <a:off x="8229600" y="1591056"/>
+            <a:ext cx="3502152" cy="1874520"/>
+          </a:xfrm>
+          <a:prstGeom prst="roundRect">
+            <a:avLst>
+              <a:gd name="adj" fmla="val 3902"/>
+            </a:avLst>
+          </a:prstGeom>
+          <a:solidFill>
+            <a:srgbClr val="007B8C"/>
+          </a:solidFill>
+          <a:ln/>
+        </p:spPr>
+        <p:txBody>
+          <a:bodyPr/>
+          <a:lstStyle/>
+          <a:p>
+            <a:endParaRPr lang="en-US"/>
+          </a:p>
+        </p:txBody>
+      </p:sp>
+      <p:sp>
+        <p:nvSpPr>
+          <p:cNvPr id="27" name="Shape 23"/>
+          <p:cNvSpPr/>
+          <p:nvPr/>
+        </p:nvSpPr>
+        <p:spPr>
+          <a:xfrm>
+            <a:off x="9724644" y="1755648"/>
+            <a:ext cx="512064" cy="512064"/>
+          </a:xfrm>
+          <a:prstGeom prst="ellipse">
+            <a:avLst/>
+          </a:prstGeom>
+          <a:solidFill>
+            <a:srgbClr val="FFFFFF"/>
+          </a:solidFill>
+          <a:ln/>
+        </p:spPr>
+        <p:txBody>
+          <a:bodyPr/>
+          <a:lstStyle/>
+          <a:p>
+            <a:endParaRPr lang="en-US"/>
+          </a:p>
+        </p:txBody>
+      </p:sp>
+      <p:pic>
+        <p:nvPicPr>
+          <p:cNvPr id="28" name="Image 2" descr="preencoded.png"/>
+          <p:cNvPicPr>
+            <a:picLocks noChangeAspect="1"/>
+          </p:cNvPicPr>
+          <p:nvPr/>
+        </p:nvPicPr>
+        <p:blipFill>
+          <a:blip r:embed="rId5"/>
+          <a:stretch>
+            <a:fillRect/>
+          </a:stretch>
+        </p:blipFill>
+        <p:spPr>
+          <a:xfrm>
+            <a:off x="9834372" y="1865376"/>
+            <a:ext cx="292608" cy="292608"/>
+          </a:xfrm>
+          <a:prstGeom prst="rect">
+            <a:avLst/>
+          </a:prstGeom>
+        </p:spPr>
+      </p:pic>
+      <p:sp>
+        <p:nvSpPr>
+          <p:cNvPr id="29" name="Text 24"/>
+          <p:cNvSpPr/>
+          <p:nvPr/>
+        </p:nvSpPr>
+        <p:spPr>
+          <a:xfrm>
+            <a:off x="8302752" y="2377440"/>
+            <a:ext cx="3355848" cy="420624"/>
+          </a:xfrm>
+          <a:prstGeom prst="rect">
+            <a:avLst/>
+          </a:prstGeom>
+          <a:noFill/>
+          <a:ln/>
+        </p:spPr>
+        <p:txBody>
+          <a:bodyPr wrap="square" lIns="0" tIns="0" rIns="0" bIns="0" rtlCol="0" anchor="t"/>
+          <a:lstStyle/>
+          <a:p>
+            <a:pPr marL="0" indent="0" algn="l">
+              <a:buNone/>
+            </a:pPr>
+            <a:r>
+              <a:rPr lang="en-US" sz="1250" b="1" dirty="0">
+                <a:solidFill>
+                  <a:srgbClr val="FFFFFF"/>
+                </a:solidFill>
+                <a:latin typeface="Arial" pitchFamily="34" charset="0"/>
+                <a:ea typeface="Arial" pitchFamily="34" charset="-122"/>
+                <a:cs typeface="Arial" pitchFamily="34" charset="-120"/>
+              </a:rPr>
+              <a:t>Why It Waits</a:t>
+            </a:r>
+            <a:endParaRPr lang="en-US" sz="1250" dirty="0"/>
+          </a:p>
+        </p:txBody>
+      </p:sp>
+      <p:sp>
+        <p:nvSpPr>
+          <p:cNvPr id="30" name="Text 25"/>
+          <p:cNvSpPr/>
+          <p:nvPr/>
+        </p:nvSpPr>
+        <p:spPr>
+          <a:xfrm>
+            <a:off x="8302752" y="2798064"/>
+            <a:ext cx="3355848" cy="594360"/>
+          </a:xfrm>
+          <a:prstGeom prst="rect">
+            <a:avLst/>
+          </a:prstGeom>
+          <a:noFill/>
+          <a:ln/>
+        </p:spPr>
+        <p:txBody>
+          <a:bodyPr wrap="square" lIns="0" tIns="0" rIns="0" bIns="0" rtlCol="0" anchor="t"/>
+          <a:lstStyle/>
+          <a:p>
+            <a:pPr marL="0" indent="0" algn="l">
+              <a:buNone/>
+            </a:pPr>
+            <a:r>
+              <a:rPr lang="en-US" sz="950" dirty="0">
+                <a:solidFill>
+                  <a:srgbClr val="EEEFF0"/>
+                </a:solidFill>
+                <a:latin typeface="Arial" pitchFamily="34" charset="0"/>
+                <a:ea typeface="Arial" pitchFamily="34" charset="-122"/>
+                <a:cs typeface="Arial" pitchFamily="34" charset="-120"/>
+              </a:rPr>
+              <a:t>Extracting a service boundary from logic that hasn't yet been validated in production risks exporting an unstable interface to new callers instead of a solid one.</a:t>
+            </a:r>
+            <a:endParaRPr lang="en-US" sz="950" dirty="0"/>
+          </a:p>
+        </p:txBody>
+      </p:sp>
+      <p:sp>
+        <p:nvSpPr>
+          <p:cNvPr id="31" name="Shape 26"/>
+          <p:cNvSpPr/>
+          <p:nvPr/>
+        </p:nvSpPr>
+        <p:spPr>
+          <a:xfrm>
+            <a:off x="4572000" y="3593592"/>
+            <a:ext cx="2264664" cy="1170432"/>
+          </a:xfrm>
+          <a:prstGeom prst="roundRect">
+            <a:avLst>
+              <a:gd name="adj" fmla="val 6250"/>
+            </a:avLst>
+          </a:prstGeom>
+          <a:solidFill>
+            <a:srgbClr val="FFFFFF"/>
+          </a:solidFill>
+          <a:ln w="9525">
+            <a:solidFill>
+              <a:srgbClr val="EEEFF0"/>
+            </a:solidFill>
+            <a:prstDash val="solid"/>
+          </a:ln>
+        </p:spPr>
+        <p:txBody>
+          <a:bodyPr/>
+          <a:lstStyle/>
+          <a:p>
+            <a:endParaRPr lang="en-US"/>
+          </a:p>
+        </p:txBody>
+      </p:sp>
+      <p:sp>
+        <p:nvSpPr>
+          <p:cNvPr id="32" name="Text 27"/>
+          <p:cNvSpPr/>
+          <p:nvPr/>
+        </p:nvSpPr>
+        <p:spPr>
+          <a:xfrm>
+            <a:off x="4709160" y="3703320"/>
+            <a:ext cx="1990344" cy="457200"/>
+          </a:xfrm>
+          <a:prstGeom prst="rect">
+            <a:avLst/>
+          </a:prstGeom>
+          <a:noFill/>
+          <a:ln/>
+        </p:spPr>
+        <p:txBody>
+          <a:bodyPr wrap="square" lIns="0" tIns="0" rIns="0" bIns="0" rtlCol="0" anchor="t"/>
+          <a:lstStyle/>
+          <a:p>
+            <a:pPr marL="0" indent="0">
+              <a:buNone/>
+            </a:pPr>
+            <a:r>
+              <a:rPr lang="en-US" sz="1800" b="1" dirty="0">
+                <a:solidFill>
+                  <a:srgbClr val="005C8A"/>
+                </a:solidFill>
+                <a:latin typeface="Arial" pitchFamily="34" charset="0"/>
+                <a:ea typeface="Arial" pitchFamily="34" charset="-122"/>
+                <a:cs typeface="Arial" pitchFamily="34" charset="-120"/>
+              </a:rPr>
+              <a:t>2</a:t>
+            </a:r>
+            <a:endParaRPr lang="en-US" sz="1800" dirty="0"/>
+          </a:p>
+        </p:txBody>
+      </p:sp>
+      <p:sp>
+        <p:nvSpPr>
+          <p:cNvPr id="33" name="Text 28"/>
+          <p:cNvSpPr/>
+          <p:nvPr/>
+        </p:nvSpPr>
+        <p:spPr>
+          <a:xfrm>
+            <a:off x="4709160" y="4160520"/>
+            <a:ext cx="1990344" cy="530352"/>
+          </a:xfrm>
+          <a:prstGeom prst="rect">
+            <a:avLst/>
+          </a:prstGeom>
+          <a:noFill/>
+          <a:ln/>
+        </p:spPr>
+        <p:txBody>
+          <a:bodyPr wrap="square" lIns="0" tIns="0" rIns="0" bIns="0" rtlCol="0" anchor="t"/>
+          <a:lstStyle/>
+          <a:p>
+            <a:pPr marL="0" indent="0">
+              <a:buNone/>
+            </a:pPr>
+            <a:r>
+              <a:rPr lang="en-US" sz="950" dirty="0">
+                <a:solidFill>
+                  <a:srgbClr val="53565A"/>
+                </a:solidFill>
+                <a:latin typeface="Arial" pitchFamily="34" charset="0"/>
+                <a:ea typeface="Arial" pitchFamily="34" charset="-122"/>
+                <a:cs typeface="Arial" pitchFamily="34" charset="-120"/>
+              </a:rPr>
+              <a:t>sampled domains (be-module, fbar-wafer) that both depend on composite identifiers</a:t>
+            </a:r>
+            <a:endParaRPr lang="en-US" sz="950" dirty="0"/>
+          </a:p>
+        </p:txBody>
+      </p:sp>
+      <p:sp>
+        <p:nvSpPr>
+          <p:cNvPr id="34" name="Shape 29"/>
+          <p:cNvSpPr/>
+          <p:nvPr/>
+        </p:nvSpPr>
+        <p:spPr>
+          <a:xfrm>
+            <a:off x="7019544" y="3593592"/>
+            <a:ext cx="2264664" cy="1170432"/>
+          </a:xfrm>
+          <a:prstGeom prst="roundRect">
+            <a:avLst>
+              <a:gd name="adj" fmla="val 6250"/>
+            </a:avLst>
+          </a:prstGeom>
+          <a:solidFill>
+            <a:srgbClr val="FFFFFF"/>
+          </a:solidFill>
+          <a:ln w="9525">
+            <a:solidFill>
+              <a:srgbClr val="EEEFF0"/>
+            </a:solidFill>
+            <a:prstDash val="solid"/>
+          </a:ln>
+        </p:spPr>
+        <p:txBody>
+          <a:bodyPr/>
+          <a:lstStyle/>
+          <a:p>
+            <a:endParaRPr lang="en-US"/>
+          </a:p>
+        </p:txBody>
+      </p:sp>
+      <p:sp>
+        <p:nvSpPr>
+          <p:cNvPr id="35" name="Text 30"/>
+          <p:cNvSpPr/>
+          <p:nvPr/>
+        </p:nvSpPr>
+        <p:spPr>
+          <a:xfrm>
+            <a:off x="7156704" y="3703320"/>
+            <a:ext cx="1990344" cy="457200"/>
+          </a:xfrm>
+          <a:prstGeom prst="rect">
+            <a:avLst/>
+          </a:prstGeom>
+          <a:noFill/>
+          <a:ln/>
+        </p:spPr>
+        <p:txBody>
+          <a:bodyPr wrap="square" lIns="0" tIns="0" rIns="0" bIns="0" rtlCol="0" anchor="t"/>
+          <a:lstStyle/>
+          <a:p>
+            <a:pPr marL="0" indent="0">
+              <a:buNone/>
+            </a:pPr>
+            <a:r>
+              <a:rPr lang="en-US" sz="1800" b="1" dirty="0">
+                <a:solidFill>
+                  <a:srgbClr val="005C8A"/>
+                </a:solidFill>
+                <a:latin typeface="Arial" pitchFamily="34" charset="0"/>
+                <a:ea typeface="Arial" pitchFamily="34" charset="-122"/>
+                <a:cs typeface="Arial" pitchFamily="34" charset="-120"/>
+              </a:rPr>
+              <a:t>0</a:t>
+            </a:r>
+            <a:endParaRPr lang="en-US" sz="1800" dirty="0"/>
+          </a:p>
+        </p:txBody>
+      </p:sp>
+      <p:sp>
+        <p:nvSpPr>
+          <p:cNvPr id="36" name="Text 31"/>
+          <p:cNvSpPr/>
+          <p:nvPr/>
+        </p:nvSpPr>
+        <p:spPr>
+          <a:xfrm>
+            <a:off x="7156704" y="4160520"/>
+            <a:ext cx="1990344" cy="530352"/>
+          </a:xfrm>
+          <a:prstGeom prst="rect">
+            <a:avLst/>
+          </a:prstGeom>
+          <a:noFill/>
+          <a:ln/>
+        </p:spPr>
+        <p:txBody>
+          <a:bodyPr wrap="square" lIns="0" tIns="0" rIns="0" bIns="0" rtlCol="0" anchor="t"/>
+          <a:lstStyle/>
+          <a:p>
+            <a:pPr marL="0" indent="0">
+              <a:buNone/>
+            </a:pPr>
+            <a:r>
+              <a:rPr lang="en-US" sz="950" dirty="0">
+                <a:solidFill>
+                  <a:srgbClr val="53565A"/>
+                </a:solidFill>
+                <a:latin typeface="Arial" pitchFamily="34" charset="0"/>
+                <a:ea typeface="Arial" pitchFamily="34" charset="-122"/>
+                <a:cs typeface="Arial" pitchFamily="34" charset="-120"/>
+              </a:rPr>
+              <a:t>production runs of v1's deterministic-assembly module so far — the gating condition</a:t>
+            </a:r>
+            <a:endParaRPr lang="en-US" sz="950" dirty="0"/>
+          </a:p>
+        </p:txBody>
+      </p:sp>
+      <p:sp>
+        <p:nvSpPr>
+          <p:cNvPr id="37" name="Shape 32"/>
+          <p:cNvSpPr/>
+          <p:nvPr/>
+        </p:nvSpPr>
+        <p:spPr>
+          <a:xfrm>
+            <a:off x="9467088" y="3593592"/>
+            <a:ext cx="2264664" cy="1170432"/>
+          </a:xfrm>
+          <a:prstGeom prst="roundRect">
+            <a:avLst>
+              <a:gd name="adj" fmla="val 6250"/>
+            </a:avLst>
+          </a:prstGeom>
+          <a:solidFill>
+            <a:srgbClr val="FFFFFF"/>
+          </a:solidFill>
+          <a:ln w="9525">
+            <a:solidFill>
+              <a:srgbClr val="EEEFF0"/>
+            </a:solidFill>
+            <a:prstDash val="solid"/>
+          </a:ln>
+        </p:spPr>
+        <p:txBody>
+          <a:bodyPr/>
+          <a:lstStyle/>
+          <a:p>
+            <a:endParaRPr lang="en-US"/>
+          </a:p>
+        </p:txBody>
+      </p:sp>
+      <p:sp>
+        <p:nvSpPr>
+          <p:cNvPr id="38" name="Text 33"/>
+          <p:cNvSpPr/>
+          <p:nvPr/>
+        </p:nvSpPr>
+        <p:spPr>
+          <a:xfrm>
+            <a:off x="9604248" y="3703320"/>
+            <a:ext cx="1990344" cy="457200"/>
+          </a:xfrm>
+          <a:prstGeom prst="rect">
+            <a:avLst/>
+          </a:prstGeom>
+          <a:noFill/>
+          <a:ln/>
+        </p:spPr>
+        <p:txBody>
+          <a:bodyPr wrap="square" lIns="0" tIns="0" rIns="0" bIns="0" rtlCol="0" anchor="t"/>
+          <a:lstStyle/>
+          <a:p>
+            <a:pPr marL="0" indent="0">
+              <a:buNone/>
+            </a:pPr>
+            <a:r>
+              <a:rPr lang="en-US" sz="1800" b="1" dirty="0">
+                <a:solidFill>
+                  <a:srgbClr val="005C8A"/>
+                </a:solidFill>
+                <a:latin typeface="Arial" pitchFamily="34" charset="0"/>
+                <a:ea typeface="Arial" pitchFamily="34" charset="-122"/>
+                <a:cs typeface="Arial" pitchFamily="34" charset="-120"/>
+              </a:rPr>
+              <a:t>Later</a:t>
+            </a:r>
+            <a:endParaRPr lang="en-US" sz="1800" dirty="0"/>
+          </a:p>
+        </p:txBody>
+      </p:sp>
+      <p:sp>
+        <p:nvSpPr>
+          <p:cNvPr id="39" name="Text 34"/>
+          <p:cNvSpPr/>
+          <p:nvPr/>
+        </p:nvSpPr>
+        <p:spPr>
+          <a:xfrm>
+            <a:off x="9604248" y="4160520"/>
+            <a:ext cx="1990344" cy="530352"/>
+          </a:xfrm>
+          <a:prstGeom prst="rect">
+            <a:avLst/>
+          </a:prstGeom>
+          <a:noFill/>
+          <a:ln/>
+        </p:spPr>
+        <p:txBody>
+          <a:bodyPr wrap="square" lIns="0" tIns="0" rIns="0" bIns="0" rtlCol="0" anchor="t"/>
+          <a:lstStyle/>
+          <a:p>
+            <a:pPr marL="0" indent="0">
+              <a:buNone/>
+            </a:pPr>
+            <a:r>
+              <a:rPr lang="en-US" sz="950" dirty="0">
+                <a:solidFill>
+                  <a:srgbClr val="53565A"/>
+                </a:solidFill>
+                <a:latin typeface="Arial" pitchFamily="34" charset="0"/>
+                <a:ea typeface="Arial" pitchFamily="34" charset="-122"/>
+                <a:cs typeface="Arial" pitchFamily="34" charset="-120"/>
+              </a:rPr>
+              <a:t>revisit timing — after v1's deterministic core proves out, not before</a:t>
+            </a:r>
+            <a:endParaRPr lang="en-US" sz="950" dirty="0"/>
+          </a:p>
+        </p:txBody>
+      </p:sp>
+      <p:sp>
+        <p:nvSpPr>
+          <p:cNvPr id="40" name="Shape 35"/>
+          <p:cNvSpPr/>
+          <p:nvPr/>
+        </p:nvSpPr>
+        <p:spPr>
+          <a:xfrm>
+            <a:off x="4572000" y="4837176"/>
+            <a:ext cx="7159752" cy="1600200"/>
+          </a:xfrm>
+          <a:prstGeom prst="rect">
+            <a:avLst/>
+          </a:prstGeom>
+          <a:solidFill>
+            <a:srgbClr val="EEEFF0"/>
+          </a:solidFill>
+          <a:ln/>
+        </p:spPr>
+        <p:txBody>
+          <a:bodyPr/>
+          <a:lstStyle/>
+          <a:p>
+            <a:endParaRPr lang="en-US"/>
+          </a:p>
+        </p:txBody>
+      </p:sp>
+      <p:pic>
+        <p:nvPicPr>
+          <p:cNvPr id="41" name="Image 3" descr="preencoded.png"/>
+          <p:cNvPicPr>
+            <a:picLocks noChangeAspect="1"/>
+          </p:cNvPicPr>
+          <p:nvPr/>
+        </p:nvPicPr>
+        <p:blipFill>
+          <a:blip r:embed="rId6"/>
+          <a:stretch>
+            <a:fillRect/>
+          </a:stretch>
+        </p:blipFill>
+        <p:spPr>
+          <a:xfrm>
+            <a:off x="4773168" y="4910328"/>
+            <a:ext cx="329184" cy="329184"/>
+          </a:xfrm>
+          <a:prstGeom prst="rect">
+            <a:avLst/>
+          </a:prstGeom>
+        </p:spPr>
+      </p:pic>
+      <p:sp>
+        <p:nvSpPr>
+          <p:cNvPr id="42" name="Text 36"/>
+          <p:cNvSpPr/>
+          <p:nvPr/>
+        </p:nvSpPr>
+        <p:spPr>
+          <a:xfrm>
+            <a:off x="5230368" y="4892040"/>
+            <a:ext cx="6309360" cy="365760"/>
+          </a:xfrm>
+          <a:prstGeom prst="rect">
+            <a:avLst/>
+          </a:prstGeom>
+          <a:noFill/>
+          <a:ln/>
+        </p:spPr>
+        <p:txBody>
+          <a:bodyPr wrap="square" lIns="0" tIns="0" rIns="0" bIns="0" rtlCol="0" anchor="t"/>
+          <a:lstStyle/>
+          <a:p>
+            <a:pPr marL="0" indent="0">
+              <a:buNone/>
+            </a:pPr>
+            <a:r>
+              <a:rPr lang="en-US" sz="1250" b="1" dirty="0">
+                <a:solidFill>
+                  <a:srgbClr val="005C8A"/>
+                </a:solidFill>
+                <a:latin typeface="Arial" pitchFamily="34" charset="0"/>
+                <a:ea typeface="Arial" pitchFamily="34" charset="-122"/>
+                <a:cs typeface="Arial" pitchFamily="34" charset="-120"/>
+              </a:rPr>
+              <a:t>WHY THIS IS HELD, NOT DROPPED</a:t>
+            </a:r>
+            <a:endParaRPr lang="en-US" sz="1250" dirty="0"/>
+          </a:p>
+        </p:txBody>
+      </p:sp>
+      <p:sp>
+        <p:nvSpPr>
+          <p:cNvPr id="43" name="Text 37"/>
+          <p:cNvSpPr/>
+          <p:nvPr/>
+        </p:nvSpPr>
+        <p:spPr>
+          <a:xfrm>
+            <a:off x="4773168" y="5294376"/>
+            <a:ext cx="6766560" cy="1051560"/>
+          </a:xfrm>
+          <a:prstGeom prst="rect">
+            <a:avLst/>
+          </a:prstGeom>
+          <a:noFill/>
+          <a:ln/>
+        </p:spPr>
+        <p:txBody>
+          <a:bodyPr wrap="square" lIns="0" tIns="0" rIns="0" bIns="0" rtlCol="0" anchor="t"/>
+          <a:lstStyle/>
+          <a:p>
+            <a:pPr marL="0" indent="0">
+              <a:lnSpc>
+                <a:spcPct val="108000"/>
+              </a:lnSpc>
+              <a:buNone/>
+            </a:pPr>
+            <a:r>
+              <a:rPr lang="en-US" sz="1050" b="1" dirty="0">
+                <a:solidFill>
+                  <a:srgbClr val="3B4652"/>
+                </a:solidFill>
+                <a:latin typeface="Arial" pitchFamily="34" charset="0"/>
+                <a:ea typeface="Arial" pitchFamily="34" charset="-122"/>
+                <a:cs typeface="Arial" pitchFamily="34" charset="-120"/>
+              </a:rPr>
+              <a:t>The SME documentation cost is already being paid inside v1 regardless of this decision. Packaging it as a separate service is nearly free incremental work once the core logic is trusted — this is a sequencing call, not a value judgment.</a:t>
             </a:r>
             <a:endParaRPr lang="en-US" sz="1050" dirty="0"/>
           </a:p>

</xml_diff>